<commit_message>
Build PAGE_07/04/10 layouts, complete all 10 page types in master template
</commit_message>
<xml_diff>
--- a/templates/master_v01.pptx
+++ b/templates/master_v01.pptx
@@ -111,6 +111,9 @@
     <p:ext uri="{EFAFB233-063F-42B5-8137-9DF3F51BA10A}">
       <p15:sldGuideLst xmlns:p15="http://schemas.microsoft.com/office/powerpoint/2012/main"/>
     </p:ext>
+    <p:ext uri="{2D200454-40CA-4A62-9FC3-DE9A4176ACB9}">
+      <p15:notesGuideLst xmlns:p15="http://schemas.microsoft.com/office/powerpoint/2012/main"/>
+    </p:ext>
   </p:extLst>
 </p:presentation>
 </file>
@@ -197,7 +200,7 @@
           <a:p>
             <a:fld id="{EB8009A7-6B9F-4D93-88A2-45E8B8D87E2F}" type="datetimeFigureOut">
               <a:rPr lang="ru-UA" smtClean="0"/>
-              <a:t>21.08.2026</a:t>
+              <a:t>27.08.2026</a:t>
             </a:fld>
             <a:endParaRPr lang="ru-UA"/>
           </a:p>
@@ -1333,7 +1336,7 @@
 
 <file path=ppt/slideLayouts/slideLayout3.xml><?xml version="1.0" encoding="utf-8"?>
 <p:sldLayout xmlns:a="http://schemas.openxmlformats.org/drawingml/2006/main" xmlns:r="http://schemas.openxmlformats.org/officeDocument/2006/relationships" xmlns:p="http://schemas.openxmlformats.org/presentationml/2006/main" preserve="1" userDrawn="1">
-  <p:cSld name="PAGE_09_SOCIAL_REACH">
+  <p:cSld name="PAGE_03_THEME_SHOWCASE">
     <p:spTree>
       <p:nvGrpSpPr>
         <p:cNvPr id="1" name=""/>
@@ -1350,10 +1353,10 @@
       </p:grpSpPr>
       <p:sp>
         <p:nvSpPr>
-          <p:cNvPr id="23" name="IMG_INSTAGRAM_MOCKUP">
-            <a:extLst>
-              <a:ext uri="{FF2B5EF4-FFF2-40B4-BE49-F238E27FC236}">
-                <a16:creationId xmlns:a16="http://schemas.microsoft.com/office/drawing/2014/main" id="{40954E10-C4C3-1647-DDBA-E8812157F0B2}"/>
+          <p:cNvPr id="7" name="IMG_THEME_WORLD_PHOTO_1">
+            <a:extLst>
+              <a:ext uri="{FF2B5EF4-FFF2-40B4-BE49-F238E27FC236}">
+                <a16:creationId xmlns:a16="http://schemas.microsoft.com/office/drawing/2014/main" id="{A6FCE4D9-629C-457C-28F0-2B2323690539}"/>
               </a:ext>
             </a:extLst>
           </p:cNvPr>
@@ -1366,8 +1369,8 @@
         </p:nvSpPr>
         <p:spPr>
           <a:xfrm>
-            <a:off x="273599" y="1602000"/>
-            <a:ext cx="4820400" cy="3618000"/>
+            <a:off x="0" y="-1"/>
+            <a:ext cx="6094800" cy="6858000"/>
           </a:xfrm>
         </p:spPr>
         <p:txBody>
@@ -1380,371 +1383,40 @@
       </p:sp>
       <p:sp>
         <p:nvSpPr>
-          <p:cNvPr id="9" name="Headline">
-            <a:extLst>
-              <a:ext uri="{FF2B5EF4-FFF2-40B4-BE49-F238E27FC236}">
-                <a16:creationId xmlns:a16="http://schemas.microsoft.com/office/drawing/2014/main" id="{B6DB5CC5-8991-97C9-24B2-159D3BDA6AC7}"/>
-              </a:ext>
-            </a:extLst>
-          </p:cNvPr>
-          <p:cNvSpPr txBox="1"/>
-          <p:nvPr userDrawn="1"/>
-        </p:nvSpPr>
-        <p:spPr>
-          <a:xfrm>
-            <a:off x="496799" y="360000"/>
-            <a:ext cx="4914000" cy="646331"/>
-          </a:xfrm>
-          <a:prstGeom prst="rect">
-            <a:avLst/>
-          </a:prstGeom>
-          <a:noFill/>
-        </p:spPr>
-        <p:txBody>
-          <a:bodyPr wrap="square" rtlCol="0">
-            <a:spAutoFit/>
-          </a:bodyPr>
-          <a:lstStyle/>
-          <a:p>
-            <a:r>
-              <a:rPr lang="de-DE" dirty="0"/>
-              <a:t>Organische Reichweite die</a:t>
-            </a:r>
-            <a:endParaRPr lang="uk-UA" dirty="0"/>
-          </a:p>
-          <a:p>
-            <a:r>
-              <a:rPr lang="de-DE" dirty="0"/>
-              <a:t>kein Werbebudget kaufen kann.</a:t>
-            </a:r>
-            <a:endParaRPr lang="ru-UA" dirty="0"/>
-          </a:p>
-        </p:txBody>
-      </p:sp>
-      <p:sp>
-        <p:nvSpPr>
-          <p:cNvPr id="10" name="Stat numbers">
-            <a:extLst>
-              <a:ext uri="{FF2B5EF4-FFF2-40B4-BE49-F238E27FC236}">
-                <a16:creationId xmlns:a16="http://schemas.microsoft.com/office/drawing/2014/main" id="{0152E84B-C2AE-DD23-E6C0-E1A4E5228142}"/>
-              </a:ext>
-            </a:extLst>
-          </p:cNvPr>
-          <p:cNvSpPr txBox="1"/>
-          <p:nvPr userDrawn="1"/>
-        </p:nvSpPr>
-        <p:spPr>
-          <a:xfrm>
-            <a:off x="6836400" y="1133998"/>
-            <a:ext cx="1389600" cy="1702800"/>
-          </a:xfrm>
-          <a:prstGeom prst="rect">
-            <a:avLst/>
-          </a:prstGeom>
-          <a:noFill/>
-        </p:spPr>
-        <p:txBody>
-          <a:bodyPr wrap="square" rtlCol="0">
-            <a:spAutoFit/>
-          </a:bodyPr>
-          <a:lstStyle/>
-          <a:p>
-            <a:r>
-              <a:rPr lang="ru-UA" dirty="0"/>
-              <a:t>90%</a:t>
-            </a:r>
-            <a:endParaRPr lang="uk-UA" dirty="0"/>
-          </a:p>
-          <a:p>
-            <a:r>
-              <a:rPr lang="ru-UA" dirty="0"/>
-              <a:t>70%</a:t>
-            </a:r>
-          </a:p>
-        </p:txBody>
-      </p:sp>
-      <p:sp>
-        <p:nvSpPr>
-          <p:cNvPr id="11" name="90% label">
-            <a:extLst>
-              <a:ext uri="{FF2B5EF4-FFF2-40B4-BE49-F238E27FC236}">
-                <a16:creationId xmlns:a16="http://schemas.microsoft.com/office/drawing/2014/main" id="{13FEF32B-4B76-15A3-8CF2-51DE08991FDB}"/>
-              </a:ext>
-            </a:extLst>
-          </p:cNvPr>
-          <p:cNvSpPr txBox="1"/>
-          <p:nvPr userDrawn="1"/>
-        </p:nvSpPr>
-        <p:spPr>
-          <a:xfrm>
-            <a:off x="8866799" y="1393200"/>
-            <a:ext cx="1566000" cy="606128"/>
-          </a:xfrm>
-          <a:prstGeom prst="rect">
-            <a:avLst/>
-          </a:prstGeom>
-          <a:noFill/>
-        </p:spPr>
-        <p:txBody>
-          <a:bodyPr wrap="square" rtlCol="0">
-            <a:spAutoFit/>
-          </a:bodyPr>
-          <a:lstStyle/>
-          <a:p>
-            <a:r>
-              <a:rPr lang="de-DE" sz="1113" baseline="0" dirty="0">
-                <a:solidFill>
-                  <a:srgbClr val="231F20"/>
-                </a:solidFill>
-                <a:latin typeface="Myriad Pro" panose="020B0503030403020204" pitchFamily="34" charset="0"/>
-              </a:rPr>
-              <a:t>der Besucher hinterlassen freiwillig ihre Kontaktdaten</a:t>
-            </a:r>
-            <a:endParaRPr lang="ru-UA" sz="1113" baseline="0" dirty="0">
-              <a:solidFill>
-                <a:srgbClr val="231F20"/>
-              </a:solidFill>
-              <a:latin typeface="Myriad Pro" panose="020B0503030403020204" pitchFamily="34" charset="0"/>
-            </a:endParaRPr>
-          </a:p>
-        </p:txBody>
-      </p:sp>
-      <p:sp>
-        <p:nvSpPr>
-          <p:cNvPr id="12" name="70% label">
-            <a:extLst>
-              <a:ext uri="{FF2B5EF4-FFF2-40B4-BE49-F238E27FC236}">
-                <a16:creationId xmlns:a16="http://schemas.microsoft.com/office/drawing/2014/main" id="{9B3F29ED-E6C9-5717-3507-04A799FC2D9D}"/>
-              </a:ext>
-            </a:extLst>
-          </p:cNvPr>
-          <p:cNvSpPr txBox="1"/>
-          <p:nvPr userDrawn="1"/>
-        </p:nvSpPr>
-        <p:spPr>
-          <a:xfrm>
-            <a:off x="8845200" y="2268000"/>
-            <a:ext cx="2080800" cy="777392"/>
-          </a:xfrm>
-          <a:prstGeom prst="rect">
-            <a:avLst/>
-          </a:prstGeom>
-          <a:noFill/>
-        </p:spPr>
-        <p:txBody>
-          <a:bodyPr wrap="square" rtlCol="0">
-            <a:spAutoFit/>
-          </a:bodyPr>
-          <a:lstStyle/>
-          <a:p>
-            <a:r>
-              <a:rPr lang="de-DE" sz="1113" baseline="0" dirty="0">
-                <a:solidFill>
-                  <a:srgbClr val="231F20"/>
-                </a:solidFill>
-                <a:latin typeface="Myriad Pro" panose="020B0503030403020204" pitchFamily="34" charset="0"/>
-              </a:rPr>
-              <a:t>teilen ihr Motiv aktiv auf Facebook, Instagram oder TikTok — mit Ihrem Markt als Kontext.</a:t>
-            </a:r>
-            <a:endParaRPr lang="ru-UA" sz="1113" baseline="0" dirty="0">
-              <a:solidFill>
-                <a:srgbClr val="231F20"/>
-              </a:solidFill>
-              <a:latin typeface="Myriad Pro" panose="020B0503030403020204" pitchFamily="34" charset="0"/>
-            </a:endParaRPr>
-          </a:p>
-        </p:txBody>
-      </p:sp>
-      <p:sp>
-        <p:nvSpPr>
-          <p:cNvPr id="14" name="Bullet 1">
-            <a:extLst>
-              <a:ext uri="{FF2B5EF4-FFF2-40B4-BE49-F238E27FC236}">
-                <a16:creationId xmlns:a16="http://schemas.microsoft.com/office/drawing/2014/main" id="{FBD4CF6E-CBF1-61F6-D34D-5BE68BF261E9}"/>
-              </a:ext>
-            </a:extLst>
-          </p:cNvPr>
-          <p:cNvSpPr txBox="1"/>
-          <p:nvPr userDrawn="1"/>
-        </p:nvSpPr>
-        <p:spPr>
-          <a:xfrm>
-            <a:off x="7660800" y="3117600"/>
-            <a:ext cx="1933200" cy="345600"/>
-          </a:xfrm>
-          <a:prstGeom prst="rect">
-            <a:avLst/>
-          </a:prstGeom>
-          <a:noFill/>
-        </p:spPr>
-        <p:txBody>
-          <a:bodyPr wrap="square" rtlCol="0">
-            <a:spAutoFit/>
-          </a:bodyPr>
-          <a:lstStyle/>
-          <a:p>
-            <a:r>
-              <a:rPr lang="de-DE" sz="1113" baseline="0" dirty="0">
-                <a:solidFill>
-                  <a:srgbClr val="231F20"/>
-                </a:solidFill>
-                <a:latin typeface="Myriad Pro" panose="020B0503030403020204" pitchFamily="34" charset="0"/>
-              </a:rPr>
-              <a:t>Ihre Besucher werden zu Markenbotschaftern Ihres Markts.</a:t>
-            </a:r>
-            <a:endParaRPr lang="ru-UA" sz="1113" baseline="0" dirty="0">
-              <a:solidFill>
-                <a:srgbClr val="231F20"/>
-              </a:solidFill>
-              <a:latin typeface="Myriad Pro" panose="020B0503030403020204" pitchFamily="34" charset="0"/>
-            </a:endParaRPr>
-          </a:p>
-        </p:txBody>
-      </p:sp>
-      <p:sp>
-        <p:nvSpPr>
-          <p:cNvPr id="15" name="Bullet 3">
-            <a:extLst>
-              <a:ext uri="{FF2B5EF4-FFF2-40B4-BE49-F238E27FC236}">
-                <a16:creationId xmlns:a16="http://schemas.microsoft.com/office/drawing/2014/main" id="{C514D626-BB0B-AB08-69DE-165E17EDECF1}"/>
-              </a:ext>
-            </a:extLst>
-          </p:cNvPr>
-          <p:cNvSpPr txBox="1"/>
-          <p:nvPr userDrawn="1"/>
-        </p:nvSpPr>
-        <p:spPr>
-          <a:xfrm>
-            <a:off x="7660800" y="3686400"/>
-            <a:ext cx="2264400" cy="434863"/>
-          </a:xfrm>
-          <a:prstGeom prst="rect">
-            <a:avLst/>
-          </a:prstGeom>
-          <a:noFill/>
-        </p:spPr>
-        <p:txBody>
-          <a:bodyPr wrap="square" rtlCol="0">
-            <a:spAutoFit/>
-          </a:bodyPr>
-          <a:lstStyle/>
-          <a:p>
-            <a:r>
-              <a:rPr lang="de-DE" sz="1113" baseline="0" dirty="0">
-                <a:solidFill>
-                  <a:srgbClr val="231F20"/>
-                </a:solidFill>
-                <a:latin typeface="Myriad Pro" panose="020B0503030403020204" pitchFamily="34" charset="0"/>
-              </a:rPr>
-              <a:t>Organischer Content, den kein Werbebudget ersetzen kann.</a:t>
-            </a:r>
-            <a:endParaRPr lang="ru-UA" sz="1113" baseline="0" dirty="0">
-              <a:solidFill>
-                <a:srgbClr val="231F20"/>
-              </a:solidFill>
-              <a:latin typeface="Myriad Pro" panose="020B0503030403020204" pitchFamily="34" charset="0"/>
-            </a:endParaRPr>
-          </a:p>
-        </p:txBody>
-      </p:sp>
-      <p:sp>
-        <p:nvSpPr>
-          <p:cNvPr id="16" name="Bullet 2">
-            <a:extLst>
-              <a:ext uri="{FF2B5EF4-FFF2-40B4-BE49-F238E27FC236}">
-                <a16:creationId xmlns:a16="http://schemas.microsoft.com/office/drawing/2014/main" id="{0D2360C0-E716-7C7C-7057-8E1AE54D65EB}"/>
-              </a:ext>
-            </a:extLst>
-          </p:cNvPr>
-          <p:cNvSpPr txBox="1"/>
-          <p:nvPr userDrawn="1"/>
-        </p:nvSpPr>
-        <p:spPr>
-          <a:xfrm>
-            <a:off x="7660800" y="4248000"/>
-            <a:ext cx="1785600" cy="606128"/>
-          </a:xfrm>
-          <a:prstGeom prst="rect">
-            <a:avLst/>
-          </a:prstGeom>
-          <a:noFill/>
-        </p:spPr>
-        <p:txBody>
-          <a:bodyPr wrap="square" rtlCol="0">
-            <a:spAutoFit/>
-          </a:bodyPr>
-          <a:lstStyle/>
-          <a:p>
-            <a:r>
-              <a:rPr lang="de-DE" sz="1113" baseline="0" dirty="0">
-                <a:solidFill>
-                  <a:srgbClr val="231F20"/>
-                </a:solidFill>
-                <a:latin typeface="Myriad Pro" panose="020B0503030403020204" pitchFamily="34" charset="0"/>
-              </a:rPr>
-              <a:t>Jedes geteilte Motiv trägt Ihren Marktnamen in die sozialen Netzwerke.</a:t>
-            </a:r>
-            <a:endParaRPr lang="ru-UA" sz="1113" baseline="0" dirty="0">
-              <a:solidFill>
-                <a:srgbClr val="231F20"/>
-              </a:solidFill>
-              <a:latin typeface="Myriad Pro" panose="020B0503030403020204" pitchFamily="34" charset="0"/>
-            </a:endParaRPr>
-          </a:p>
-        </p:txBody>
-      </p:sp>
-      <p:sp>
-        <p:nvSpPr>
-          <p:cNvPr id="17" name="TextBox 16">
-            <a:extLst>
-              <a:ext uri="{FF2B5EF4-FFF2-40B4-BE49-F238E27FC236}">
-                <a16:creationId xmlns:a16="http://schemas.microsoft.com/office/drawing/2014/main" id="{7186F38D-32EB-3F34-97DF-A0289561AC92}"/>
-              </a:ext>
-            </a:extLst>
-          </p:cNvPr>
-          <p:cNvSpPr txBox="1"/>
-          <p:nvPr userDrawn="1"/>
-        </p:nvSpPr>
-        <p:spPr>
-          <a:xfrm>
-            <a:off x="7660799" y="5043600"/>
-            <a:ext cx="3168000" cy="961802"/>
-          </a:xfrm>
-          <a:prstGeom prst="rect">
-            <a:avLst/>
-          </a:prstGeom>
-          <a:noFill/>
-        </p:spPr>
-        <p:txBody>
-          <a:bodyPr wrap="square" rtlCol="0">
-            <a:spAutoFit/>
-          </a:bodyPr>
-          <a:lstStyle/>
-          <a:p>
-            <a:r>
-              <a:rPr lang="de-DE" sz="1130" baseline="0" dirty="0">
-                <a:solidFill>
-                  <a:srgbClr val="231F20"/>
-                </a:solidFill>
-                <a:latin typeface="Myriad Pro" panose="020B0503030403020204" pitchFamily="34" charset="0"/>
-              </a:rPr>
-              <a:t>Nach der Saison erhalten Sie von uns eine vollständige Auswertung — welche Motive am häufigsten geteilt wurden, welche Masken am besten ankamen, und wie wir das Erlebnis für die nächste Saison gemeinsam weiterentwickeln.</a:t>
-            </a:r>
-            <a:endParaRPr lang="ru-UA" sz="1130" baseline="0" dirty="0">
-              <a:solidFill>
-                <a:srgbClr val="231F20"/>
-              </a:solidFill>
-              <a:latin typeface="Myriad Pro" panose="020B0503030403020204" pitchFamily="34" charset="0"/>
-            </a:endParaRPr>
-          </a:p>
-        </p:txBody>
-      </p:sp>
-      <p:sp>
-        <p:nvSpPr>
-          <p:cNvPr id="19" name="Прямокутник 18">
-            <a:extLst>
-              <a:ext uri="{FF2B5EF4-FFF2-40B4-BE49-F238E27FC236}">
-                <a16:creationId xmlns:a16="http://schemas.microsoft.com/office/drawing/2014/main" id="{14A34DD9-A31A-53B9-67F1-BE7D2951E149}"/>
+          <p:cNvPr id="9" name="IMG_THEME_WORLD_PHOTO_2">
+            <a:extLst>
+              <a:ext uri="{FF2B5EF4-FFF2-40B4-BE49-F238E27FC236}">
+                <a16:creationId xmlns:a16="http://schemas.microsoft.com/office/drawing/2014/main" id="{355E0EDF-FAA7-B038-2D55-A18F6454E794}"/>
+              </a:ext>
+            </a:extLst>
+          </p:cNvPr>
+          <p:cNvSpPr>
+            <a:spLocks noGrp="1"/>
+          </p:cNvSpPr>
+          <p:nvPr>
+            <p:ph type="pic" sz="quarter" idx="11"/>
+          </p:nvPr>
+        </p:nvSpPr>
+        <p:spPr>
+          <a:xfrm>
+            <a:off x="6094800" y="-1"/>
+            <a:ext cx="6094800" cy="6858000"/>
+          </a:xfrm>
+        </p:spPr>
+        <p:txBody>
+          <a:bodyPr/>
+          <a:lstStyle/>
+          <a:p>
+            <a:endParaRPr lang="ru-UA"/>
+          </a:p>
+        </p:txBody>
+      </p:sp>
+      <p:sp>
+        <p:nvSpPr>
+          <p:cNvPr id="13" name="Прямокутник 12">
+            <a:extLst>
+              <a:ext uri="{FF2B5EF4-FFF2-40B4-BE49-F238E27FC236}">
+                <a16:creationId xmlns:a16="http://schemas.microsoft.com/office/drawing/2014/main" id="{51459395-9D7C-2DB4-0DB1-E623660D2896}"/>
               </a:ext>
             </a:extLst>
           </p:cNvPr>
@@ -1753,19 +1425,20 @@
         </p:nvSpPr>
         <p:spPr>
           <a:xfrm>
-            <a:off x="7023600" y="3088800"/>
-            <a:ext cx="327600" cy="327600"/>
+            <a:off x="262799" y="273600"/>
+            <a:ext cx="3934800" cy="676800"/>
           </a:xfrm>
           <a:prstGeom prst="rect">
             <a:avLst/>
           </a:prstGeom>
           <a:solidFill>
-            <a:srgbClr val="001319"/>
+            <a:schemeClr val="bg1">
+              <a:lumMod val="10000"/>
+              <a:alpha val="60000"/>
+            </a:schemeClr>
           </a:solidFill>
-          <a:ln w="19050">
-            <a:solidFill>
-              <a:srgbClr val="C5923B"/>
-            </a:solidFill>
+          <a:ln>
+            <a:noFill/>
           </a:ln>
         </p:spPr>
         <p:style>
@@ -1795,10 +1468,10 @@
       </p:sp>
       <p:sp>
         <p:nvSpPr>
-          <p:cNvPr id="20" name="Прямокутник 19">
-            <a:extLst>
-              <a:ext uri="{FF2B5EF4-FFF2-40B4-BE49-F238E27FC236}">
-                <a16:creationId xmlns:a16="http://schemas.microsoft.com/office/drawing/2014/main" id="{AE6472B1-78B2-51E9-DF35-4441909DA0EA}"/>
+          <p:cNvPr id="14" name="Прямокутник 13">
+            <a:extLst>
+              <a:ext uri="{FF2B5EF4-FFF2-40B4-BE49-F238E27FC236}">
+                <a16:creationId xmlns:a16="http://schemas.microsoft.com/office/drawing/2014/main" id="{4568C7C3-A128-9C36-204A-1CF987F42DD2}"/>
               </a:ext>
             </a:extLst>
           </p:cNvPr>
@@ -1807,19 +1480,20 @@
         </p:nvSpPr>
         <p:spPr>
           <a:xfrm>
-            <a:off x="7023600" y="3639600"/>
-            <a:ext cx="327600" cy="327600"/>
+            <a:off x="6357600" y="273600"/>
+            <a:ext cx="3934800" cy="676800"/>
           </a:xfrm>
           <a:prstGeom prst="rect">
             <a:avLst/>
           </a:prstGeom>
           <a:solidFill>
-            <a:srgbClr val="001319"/>
+            <a:schemeClr val="bg1">
+              <a:lumMod val="10000"/>
+              <a:alpha val="60000"/>
+            </a:schemeClr>
           </a:solidFill>
-          <a:ln w="19050">
-            <a:solidFill>
-              <a:srgbClr val="C5923B"/>
-            </a:solidFill>
+          <a:ln>
+            <a:noFill/>
           </a:ln>
         </p:spPr>
         <p:style>
@@ -1849,10 +1523,581 @@
       </p:sp>
       <p:sp>
         <p:nvSpPr>
-          <p:cNvPr id="21" name="Прямокутник 20">
-            <a:extLst>
-              <a:ext uri="{FF2B5EF4-FFF2-40B4-BE49-F238E27FC236}">
-                <a16:creationId xmlns:a16="http://schemas.microsoft.com/office/drawing/2014/main" id="{5BDFD734-B7FA-80E7-4DFB-D2B80BF97973}"/>
+          <p:cNvPr id="11" name="TXT_THEME_WORLD_NAME_1">
+            <a:extLst>
+              <a:ext uri="{FF2B5EF4-FFF2-40B4-BE49-F238E27FC236}">
+                <a16:creationId xmlns:a16="http://schemas.microsoft.com/office/drawing/2014/main" id="{2850ECA9-D7FE-0421-B08C-1502F74F816D}"/>
+              </a:ext>
+            </a:extLst>
+          </p:cNvPr>
+          <p:cNvSpPr>
+            <a:spLocks noGrp="1"/>
+          </p:cNvSpPr>
+          <p:nvPr>
+            <p:ph type="body" sz="quarter" idx="12"/>
+          </p:nvPr>
+        </p:nvSpPr>
+        <p:spPr>
+          <a:xfrm>
+            <a:off x="511199" y="396000"/>
+            <a:ext cx="3420000" cy="374400"/>
+          </a:xfrm>
+        </p:spPr>
+        <p:txBody>
+          <a:bodyPr/>
+          <a:lstStyle>
+            <a:lvl1pPr>
+              <a:buNone/>
+              <a:defRPr sz="2741" baseline="0">
+                <a:solidFill>
+                  <a:srgbClr val="F2F0EE"/>
+                </a:solidFill>
+              </a:defRPr>
+            </a:lvl1pPr>
+            <a:lvl2pPr>
+              <a:buNone/>
+              <a:defRPr sz="2741" baseline="0">
+                <a:solidFill>
+                  <a:srgbClr val="F2F0EE"/>
+                </a:solidFill>
+              </a:defRPr>
+            </a:lvl2pPr>
+            <a:lvl3pPr>
+              <a:buNone/>
+              <a:defRPr sz="2741" baseline="0">
+                <a:solidFill>
+                  <a:srgbClr val="F2F0EE"/>
+                </a:solidFill>
+              </a:defRPr>
+            </a:lvl3pPr>
+            <a:lvl4pPr>
+              <a:buNone/>
+              <a:defRPr sz="2741" baseline="0">
+                <a:solidFill>
+                  <a:srgbClr val="F2F0EE"/>
+                </a:solidFill>
+              </a:defRPr>
+            </a:lvl4pPr>
+            <a:lvl5pPr>
+              <a:buNone/>
+              <a:defRPr sz="2741" baseline="0">
+                <a:solidFill>
+                  <a:srgbClr val="F2F0EE"/>
+                </a:solidFill>
+              </a:defRPr>
+            </a:lvl5pPr>
+          </a:lstStyle>
+          <a:p>
+            <a:pPr lvl="0"/>
+            <a:r>
+              <a:rPr lang="uk-UA" dirty="0"/>
+              <a:t>Клацніть</a:t>
+            </a:r>
+          </a:p>
+        </p:txBody>
+      </p:sp>
+      <p:sp>
+        <p:nvSpPr>
+          <p:cNvPr id="12" name="TXT_THEME_WORLD_NAME_2">
+            <a:extLst>
+              <a:ext uri="{FF2B5EF4-FFF2-40B4-BE49-F238E27FC236}">
+                <a16:creationId xmlns:a16="http://schemas.microsoft.com/office/drawing/2014/main" id="{C0934698-967E-BA7B-8398-8BED3B57BA0F}"/>
+              </a:ext>
+            </a:extLst>
+          </p:cNvPr>
+          <p:cNvSpPr>
+            <a:spLocks noGrp="1"/>
+          </p:cNvSpPr>
+          <p:nvPr>
+            <p:ph type="body" sz="quarter" idx="13"/>
+          </p:nvPr>
+        </p:nvSpPr>
+        <p:spPr>
+          <a:xfrm>
+            <a:off x="6606000" y="396000"/>
+            <a:ext cx="3420000" cy="374400"/>
+          </a:xfrm>
+        </p:spPr>
+        <p:txBody>
+          <a:bodyPr/>
+          <a:lstStyle>
+            <a:lvl1pPr>
+              <a:buNone/>
+              <a:defRPr sz="2741" baseline="0">
+                <a:solidFill>
+                  <a:srgbClr val="F2F0EE"/>
+                </a:solidFill>
+              </a:defRPr>
+            </a:lvl1pPr>
+            <a:lvl2pPr>
+              <a:buNone/>
+              <a:defRPr sz="2741" baseline="0">
+                <a:solidFill>
+                  <a:srgbClr val="F2F0EE"/>
+                </a:solidFill>
+              </a:defRPr>
+            </a:lvl2pPr>
+            <a:lvl3pPr>
+              <a:buNone/>
+              <a:defRPr sz="2741" baseline="0">
+                <a:solidFill>
+                  <a:srgbClr val="F2F0EE"/>
+                </a:solidFill>
+              </a:defRPr>
+            </a:lvl3pPr>
+            <a:lvl4pPr>
+              <a:buNone/>
+              <a:defRPr sz="2741" baseline="0">
+                <a:solidFill>
+                  <a:srgbClr val="F2F0EE"/>
+                </a:solidFill>
+              </a:defRPr>
+            </a:lvl4pPr>
+            <a:lvl5pPr>
+              <a:buNone/>
+              <a:defRPr sz="2741" baseline="0">
+                <a:solidFill>
+                  <a:srgbClr val="F2F0EE"/>
+                </a:solidFill>
+              </a:defRPr>
+            </a:lvl5pPr>
+          </a:lstStyle>
+          <a:p>
+            <a:pPr lvl="0"/>
+            <a:r>
+              <a:rPr lang="uk-UA" dirty="0"/>
+              <a:t>Клацніть</a:t>
+            </a:r>
+          </a:p>
+        </p:txBody>
+      </p:sp>
+    </p:spTree>
+    <p:extLst>
+      <p:ext uri="{BB962C8B-B14F-4D97-AF65-F5344CB8AC3E}">
+        <p14:creationId xmlns:p14="http://schemas.microsoft.com/office/powerpoint/2010/main" val="3346131210"/>
+      </p:ext>
+    </p:extLst>
+  </p:cSld>
+  <p:clrMapOvr>
+    <a:masterClrMapping/>
+  </p:clrMapOvr>
+</p:sldLayout>
+</file>
+
+<file path=ppt/slideLayouts/slideLayout4.xml><?xml version="1.0" encoding="utf-8"?>
+<p:sldLayout xmlns:a="http://schemas.openxmlformats.org/drawingml/2006/main" xmlns:r="http://schemas.openxmlformats.org/officeDocument/2006/relationships" xmlns:p="http://schemas.openxmlformats.org/presentationml/2006/main" preserve="1" userDrawn="1">
+  <p:cSld name="PAGE_09_SOCIAL_REACH">
+    <p:spTree>
+      <p:nvGrpSpPr>
+        <p:cNvPr id="1" name=""/>
+        <p:cNvGrpSpPr/>
+        <p:nvPr/>
+      </p:nvGrpSpPr>
+      <p:grpSpPr>
+        <a:xfrm>
+          <a:off x="0" y="0"/>
+          <a:ext cx="0" cy="0"/>
+          <a:chOff x="0" y="0"/>
+          <a:chExt cx="0" cy="0"/>
+        </a:xfrm>
+      </p:grpSpPr>
+      <p:sp>
+        <p:nvSpPr>
+          <p:cNvPr id="23" name="IMG_INSTAGRAM_MOCKUP">
+            <a:extLst>
+              <a:ext uri="{FF2B5EF4-FFF2-40B4-BE49-F238E27FC236}">
+                <a16:creationId xmlns:a16="http://schemas.microsoft.com/office/drawing/2014/main" id="{40954E10-C4C3-1647-DDBA-E8812157F0B2}"/>
+              </a:ext>
+            </a:extLst>
+          </p:cNvPr>
+          <p:cNvSpPr>
+            <a:spLocks noGrp="1"/>
+          </p:cNvSpPr>
+          <p:nvPr>
+            <p:ph type="pic" sz="quarter" idx="10"/>
+          </p:nvPr>
+        </p:nvSpPr>
+        <p:spPr>
+          <a:xfrm>
+            <a:off x="273599" y="1602000"/>
+            <a:ext cx="4820400" cy="3618000"/>
+          </a:xfrm>
+        </p:spPr>
+        <p:txBody>
+          <a:bodyPr/>
+          <a:lstStyle/>
+          <a:p>
+            <a:endParaRPr lang="ru-UA"/>
+          </a:p>
+        </p:txBody>
+      </p:sp>
+      <p:sp>
+        <p:nvSpPr>
+          <p:cNvPr id="9" name="Headline">
+            <a:extLst>
+              <a:ext uri="{FF2B5EF4-FFF2-40B4-BE49-F238E27FC236}">
+                <a16:creationId xmlns:a16="http://schemas.microsoft.com/office/drawing/2014/main" id="{B6DB5CC5-8991-97C9-24B2-159D3BDA6AC7}"/>
+              </a:ext>
+            </a:extLst>
+          </p:cNvPr>
+          <p:cNvSpPr txBox="1"/>
+          <p:nvPr userDrawn="1"/>
+        </p:nvSpPr>
+        <p:spPr>
+          <a:xfrm>
+            <a:off x="496799" y="360000"/>
+            <a:ext cx="4914000" cy="646331"/>
+          </a:xfrm>
+          <a:prstGeom prst="rect">
+            <a:avLst/>
+          </a:prstGeom>
+          <a:noFill/>
+        </p:spPr>
+        <p:txBody>
+          <a:bodyPr wrap="square" rtlCol="0">
+            <a:spAutoFit/>
+          </a:bodyPr>
+          <a:lstStyle/>
+          <a:p>
+            <a:r>
+              <a:rPr lang="de-DE" dirty="0"/>
+              <a:t>Organische Reichweite die</a:t>
+            </a:r>
+            <a:endParaRPr lang="uk-UA" dirty="0"/>
+          </a:p>
+          <a:p>
+            <a:r>
+              <a:rPr lang="de-DE" dirty="0"/>
+              <a:t>kein Werbebudget kaufen kann.</a:t>
+            </a:r>
+            <a:endParaRPr lang="ru-UA" dirty="0"/>
+          </a:p>
+        </p:txBody>
+      </p:sp>
+      <p:sp>
+        <p:nvSpPr>
+          <p:cNvPr id="10" name="Stat numbers">
+            <a:extLst>
+              <a:ext uri="{FF2B5EF4-FFF2-40B4-BE49-F238E27FC236}">
+                <a16:creationId xmlns:a16="http://schemas.microsoft.com/office/drawing/2014/main" id="{0152E84B-C2AE-DD23-E6C0-E1A4E5228142}"/>
+              </a:ext>
+            </a:extLst>
+          </p:cNvPr>
+          <p:cNvSpPr txBox="1"/>
+          <p:nvPr userDrawn="1"/>
+        </p:nvSpPr>
+        <p:spPr>
+          <a:xfrm>
+            <a:off x="6836400" y="1133998"/>
+            <a:ext cx="1389600" cy="1702800"/>
+          </a:xfrm>
+          <a:prstGeom prst="rect">
+            <a:avLst/>
+          </a:prstGeom>
+          <a:noFill/>
+        </p:spPr>
+        <p:txBody>
+          <a:bodyPr wrap="square" rtlCol="0">
+            <a:spAutoFit/>
+          </a:bodyPr>
+          <a:lstStyle/>
+          <a:p>
+            <a:r>
+              <a:rPr lang="ru-UA" dirty="0"/>
+              <a:t>90%</a:t>
+            </a:r>
+            <a:endParaRPr lang="uk-UA" dirty="0"/>
+          </a:p>
+          <a:p>
+            <a:r>
+              <a:rPr lang="ru-UA" dirty="0"/>
+              <a:t>70%</a:t>
+            </a:r>
+          </a:p>
+        </p:txBody>
+      </p:sp>
+      <p:sp>
+        <p:nvSpPr>
+          <p:cNvPr id="11" name="90% label">
+            <a:extLst>
+              <a:ext uri="{FF2B5EF4-FFF2-40B4-BE49-F238E27FC236}">
+                <a16:creationId xmlns:a16="http://schemas.microsoft.com/office/drawing/2014/main" id="{13FEF32B-4B76-15A3-8CF2-51DE08991FDB}"/>
+              </a:ext>
+            </a:extLst>
+          </p:cNvPr>
+          <p:cNvSpPr txBox="1"/>
+          <p:nvPr userDrawn="1"/>
+        </p:nvSpPr>
+        <p:spPr>
+          <a:xfrm>
+            <a:off x="8866799" y="1393200"/>
+            <a:ext cx="1566000" cy="606128"/>
+          </a:xfrm>
+          <a:prstGeom prst="rect">
+            <a:avLst/>
+          </a:prstGeom>
+          <a:noFill/>
+        </p:spPr>
+        <p:txBody>
+          <a:bodyPr wrap="square" rtlCol="0">
+            <a:spAutoFit/>
+          </a:bodyPr>
+          <a:lstStyle/>
+          <a:p>
+            <a:r>
+              <a:rPr lang="de-DE" sz="1113" baseline="0" dirty="0">
+                <a:solidFill>
+                  <a:srgbClr val="231F20"/>
+                </a:solidFill>
+                <a:latin typeface="Myriad Pro" panose="020B0503030403020204" pitchFamily="34" charset="0"/>
+              </a:rPr>
+              <a:t>der Besucher hinterlassen freiwillig ihre Kontaktdaten</a:t>
+            </a:r>
+            <a:endParaRPr lang="ru-UA" sz="1113" baseline="0" dirty="0">
+              <a:solidFill>
+                <a:srgbClr val="231F20"/>
+              </a:solidFill>
+              <a:latin typeface="Myriad Pro" panose="020B0503030403020204" pitchFamily="34" charset="0"/>
+            </a:endParaRPr>
+          </a:p>
+        </p:txBody>
+      </p:sp>
+      <p:sp>
+        <p:nvSpPr>
+          <p:cNvPr id="12" name="70% label">
+            <a:extLst>
+              <a:ext uri="{FF2B5EF4-FFF2-40B4-BE49-F238E27FC236}">
+                <a16:creationId xmlns:a16="http://schemas.microsoft.com/office/drawing/2014/main" id="{9B3F29ED-E6C9-5717-3507-04A799FC2D9D}"/>
+              </a:ext>
+            </a:extLst>
+          </p:cNvPr>
+          <p:cNvSpPr txBox="1"/>
+          <p:nvPr userDrawn="1"/>
+        </p:nvSpPr>
+        <p:spPr>
+          <a:xfrm>
+            <a:off x="8845200" y="2268000"/>
+            <a:ext cx="2080800" cy="777392"/>
+          </a:xfrm>
+          <a:prstGeom prst="rect">
+            <a:avLst/>
+          </a:prstGeom>
+          <a:noFill/>
+        </p:spPr>
+        <p:txBody>
+          <a:bodyPr wrap="square" rtlCol="0">
+            <a:spAutoFit/>
+          </a:bodyPr>
+          <a:lstStyle/>
+          <a:p>
+            <a:r>
+              <a:rPr lang="de-DE" sz="1113" baseline="0" dirty="0">
+                <a:solidFill>
+                  <a:srgbClr val="231F20"/>
+                </a:solidFill>
+                <a:latin typeface="Myriad Pro" panose="020B0503030403020204" pitchFamily="34" charset="0"/>
+              </a:rPr>
+              <a:t>teilen ihr Motiv aktiv auf Facebook, Instagram oder TikTok — mit Ihrem Markt als Kontext.</a:t>
+            </a:r>
+            <a:endParaRPr lang="ru-UA" sz="1113" baseline="0" dirty="0">
+              <a:solidFill>
+                <a:srgbClr val="231F20"/>
+              </a:solidFill>
+              <a:latin typeface="Myriad Pro" panose="020B0503030403020204" pitchFamily="34" charset="0"/>
+            </a:endParaRPr>
+          </a:p>
+        </p:txBody>
+      </p:sp>
+      <p:sp>
+        <p:nvSpPr>
+          <p:cNvPr id="14" name="Bullet 1">
+            <a:extLst>
+              <a:ext uri="{FF2B5EF4-FFF2-40B4-BE49-F238E27FC236}">
+                <a16:creationId xmlns:a16="http://schemas.microsoft.com/office/drawing/2014/main" id="{FBD4CF6E-CBF1-61F6-D34D-5BE68BF261E9}"/>
+              </a:ext>
+            </a:extLst>
+          </p:cNvPr>
+          <p:cNvSpPr txBox="1"/>
+          <p:nvPr userDrawn="1"/>
+        </p:nvSpPr>
+        <p:spPr>
+          <a:xfrm>
+            <a:off x="7660800" y="3117600"/>
+            <a:ext cx="1933200" cy="345600"/>
+          </a:xfrm>
+          <a:prstGeom prst="rect">
+            <a:avLst/>
+          </a:prstGeom>
+          <a:noFill/>
+        </p:spPr>
+        <p:txBody>
+          <a:bodyPr wrap="square" rtlCol="0">
+            <a:spAutoFit/>
+          </a:bodyPr>
+          <a:lstStyle/>
+          <a:p>
+            <a:r>
+              <a:rPr lang="de-DE" sz="1113" baseline="0" dirty="0">
+                <a:solidFill>
+                  <a:srgbClr val="231F20"/>
+                </a:solidFill>
+                <a:latin typeface="Myriad Pro" panose="020B0503030403020204" pitchFamily="34" charset="0"/>
+              </a:rPr>
+              <a:t>Ihre Besucher werden zu Markenbotschaftern Ihres Markts.</a:t>
+            </a:r>
+            <a:endParaRPr lang="ru-UA" sz="1113" baseline="0" dirty="0">
+              <a:solidFill>
+                <a:srgbClr val="231F20"/>
+              </a:solidFill>
+              <a:latin typeface="Myriad Pro" panose="020B0503030403020204" pitchFamily="34" charset="0"/>
+            </a:endParaRPr>
+          </a:p>
+        </p:txBody>
+      </p:sp>
+      <p:sp>
+        <p:nvSpPr>
+          <p:cNvPr id="15" name="Bullet 3">
+            <a:extLst>
+              <a:ext uri="{FF2B5EF4-FFF2-40B4-BE49-F238E27FC236}">
+                <a16:creationId xmlns:a16="http://schemas.microsoft.com/office/drawing/2014/main" id="{C514D626-BB0B-AB08-69DE-165E17EDECF1}"/>
+              </a:ext>
+            </a:extLst>
+          </p:cNvPr>
+          <p:cNvSpPr txBox="1"/>
+          <p:nvPr userDrawn="1"/>
+        </p:nvSpPr>
+        <p:spPr>
+          <a:xfrm>
+            <a:off x="7660800" y="3686400"/>
+            <a:ext cx="2264400" cy="434863"/>
+          </a:xfrm>
+          <a:prstGeom prst="rect">
+            <a:avLst/>
+          </a:prstGeom>
+          <a:noFill/>
+        </p:spPr>
+        <p:txBody>
+          <a:bodyPr wrap="square" rtlCol="0">
+            <a:spAutoFit/>
+          </a:bodyPr>
+          <a:lstStyle/>
+          <a:p>
+            <a:r>
+              <a:rPr lang="de-DE" sz="1113" baseline="0" dirty="0">
+                <a:solidFill>
+                  <a:srgbClr val="231F20"/>
+                </a:solidFill>
+                <a:latin typeface="Myriad Pro" panose="020B0503030403020204" pitchFamily="34" charset="0"/>
+              </a:rPr>
+              <a:t>Organischer Content, den kein Werbebudget ersetzen kann.</a:t>
+            </a:r>
+            <a:endParaRPr lang="ru-UA" sz="1113" baseline="0" dirty="0">
+              <a:solidFill>
+                <a:srgbClr val="231F20"/>
+              </a:solidFill>
+              <a:latin typeface="Myriad Pro" panose="020B0503030403020204" pitchFamily="34" charset="0"/>
+            </a:endParaRPr>
+          </a:p>
+        </p:txBody>
+      </p:sp>
+      <p:sp>
+        <p:nvSpPr>
+          <p:cNvPr id="16" name="Bullet 2">
+            <a:extLst>
+              <a:ext uri="{FF2B5EF4-FFF2-40B4-BE49-F238E27FC236}">
+                <a16:creationId xmlns:a16="http://schemas.microsoft.com/office/drawing/2014/main" id="{0D2360C0-E716-7C7C-7057-8E1AE54D65EB}"/>
+              </a:ext>
+            </a:extLst>
+          </p:cNvPr>
+          <p:cNvSpPr txBox="1"/>
+          <p:nvPr userDrawn="1"/>
+        </p:nvSpPr>
+        <p:spPr>
+          <a:xfrm>
+            <a:off x="7660800" y="4248000"/>
+            <a:ext cx="1785600" cy="606128"/>
+          </a:xfrm>
+          <a:prstGeom prst="rect">
+            <a:avLst/>
+          </a:prstGeom>
+          <a:noFill/>
+        </p:spPr>
+        <p:txBody>
+          <a:bodyPr wrap="square" rtlCol="0">
+            <a:spAutoFit/>
+          </a:bodyPr>
+          <a:lstStyle/>
+          <a:p>
+            <a:r>
+              <a:rPr lang="de-DE" sz="1113" baseline="0" dirty="0">
+                <a:solidFill>
+                  <a:srgbClr val="231F20"/>
+                </a:solidFill>
+                <a:latin typeface="Myriad Pro" panose="020B0503030403020204" pitchFamily="34" charset="0"/>
+              </a:rPr>
+              <a:t>Jedes geteilte Motiv trägt Ihren Marktnamen in die sozialen Netzwerke.</a:t>
+            </a:r>
+            <a:endParaRPr lang="ru-UA" sz="1113" baseline="0" dirty="0">
+              <a:solidFill>
+                <a:srgbClr val="231F20"/>
+              </a:solidFill>
+              <a:latin typeface="Myriad Pro" panose="020B0503030403020204" pitchFamily="34" charset="0"/>
+            </a:endParaRPr>
+          </a:p>
+        </p:txBody>
+      </p:sp>
+      <p:sp>
+        <p:nvSpPr>
+          <p:cNvPr id="17" name="TextBox 16">
+            <a:extLst>
+              <a:ext uri="{FF2B5EF4-FFF2-40B4-BE49-F238E27FC236}">
+                <a16:creationId xmlns:a16="http://schemas.microsoft.com/office/drawing/2014/main" id="{7186F38D-32EB-3F34-97DF-A0289561AC92}"/>
+              </a:ext>
+            </a:extLst>
+          </p:cNvPr>
+          <p:cNvSpPr txBox="1"/>
+          <p:nvPr userDrawn="1"/>
+        </p:nvSpPr>
+        <p:spPr>
+          <a:xfrm>
+            <a:off x="7660799" y="5043600"/>
+            <a:ext cx="3168000" cy="961802"/>
+          </a:xfrm>
+          <a:prstGeom prst="rect">
+            <a:avLst/>
+          </a:prstGeom>
+          <a:noFill/>
+        </p:spPr>
+        <p:txBody>
+          <a:bodyPr wrap="square" rtlCol="0">
+            <a:spAutoFit/>
+          </a:bodyPr>
+          <a:lstStyle/>
+          <a:p>
+            <a:r>
+              <a:rPr lang="de-DE" sz="1130" baseline="0" dirty="0">
+                <a:solidFill>
+                  <a:srgbClr val="231F20"/>
+                </a:solidFill>
+                <a:latin typeface="Myriad Pro" panose="020B0503030403020204" pitchFamily="34" charset="0"/>
+              </a:rPr>
+              <a:t>Nach der Saison erhalten Sie von uns eine vollständige Auswertung — welche Motive am häufigsten geteilt wurden, welche Masken am besten ankamen, und wie wir das Erlebnis für die nächste Saison gemeinsam weiterentwickeln.</a:t>
+            </a:r>
+            <a:endParaRPr lang="ru-UA" sz="1130" baseline="0" dirty="0">
+              <a:solidFill>
+                <a:srgbClr val="231F20"/>
+              </a:solidFill>
+              <a:latin typeface="Myriad Pro" panose="020B0503030403020204" pitchFamily="34" charset="0"/>
+            </a:endParaRPr>
+          </a:p>
+        </p:txBody>
+      </p:sp>
+      <p:sp>
+        <p:nvSpPr>
+          <p:cNvPr id="19" name="Прямокутник 18">
+            <a:extLst>
+              <a:ext uri="{FF2B5EF4-FFF2-40B4-BE49-F238E27FC236}">
+                <a16:creationId xmlns:a16="http://schemas.microsoft.com/office/drawing/2014/main" id="{14A34DD9-A31A-53B9-67F1-BE7D2951E149}"/>
               </a:ext>
             </a:extLst>
           </p:cNvPr>
@@ -1861,7 +2106,7 @@
         </p:nvSpPr>
         <p:spPr>
           <a:xfrm>
-            <a:off x="7023600" y="4190400"/>
+            <a:off x="7023600" y="3088800"/>
             <a:ext cx="327600" cy="327600"/>
           </a:xfrm>
           <a:prstGeom prst="rect">
@@ -1901,6 +2146,114 @@
           </a:p>
         </p:txBody>
       </p:sp>
+      <p:sp>
+        <p:nvSpPr>
+          <p:cNvPr id="20" name="Прямокутник 19">
+            <a:extLst>
+              <a:ext uri="{FF2B5EF4-FFF2-40B4-BE49-F238E27FC236}">
+                <a16:creationId xmlns:a16="http://schemas.microsoft.com/office/drawing/2014/main" id="{AE6472B1-78B2-51E9-DF35-4441909DA0EA}"/>
+              </a:ext>
+            </a:extLst>
+          </p:cNvPr>
+          <p:cNvSpPr/>
+          <p:nvPr userDrawn="1"/>
+        </p:nvSpPr>
+        <p:spPr>
+          <a:xfrm>
+            <a:off x="7023600" y="3639600"/>
+            <a:ext cx="327600" cy="327600"/>
+          </a:xfrm>
+          <a:prstGeom prst="rect">
+            <a:avLst/>
+          </a:prstGeom>
+          <a:solidFill>
+            <a:srgbClr val="001319"/>
+          </a:solidFill>
+          <a:ln w="19050">
+            <a:solidFill>
+              <a:srgbClr val="C5923B"/>
+            </a:solidFill>
+          </a:ln>
+        </p:spPr>
+        <p:style>
+          <a:lnRef idx="2">
+            <a:schemeClr val="accent1">
+              <a:shade val="15000"/>
+            </a:schemeClr>
+          </a:lnRef>
+          <a:fillRef idx="1">
+            <a:schemeClr val="accent1"/>
+          </a:fillRef>
+          <a:effectRef idx="0">
+            <a:schemeClr val="accent1"/>
+          </a:effectRef>
+          <a:fontRef idx="minor">
+            <a:schemeClr val="lt1"/>
+          </a:fontRef>
+        </p:style>
+        <p:txBody>
+          <a:bodyPr rtlCol="0" anchor="ctr"/>
+          <a:lstStyle/>
+          <a:p>
+            <a:pPr algn="ctr"/>
+            <a:endParaRPr lang="ru-UA"/>
+          </a:p>
+        </p:txBody>
+      </p:sp>
+      <p:sp>
+        <p:nvSpPr>
+          <p:cNvPr id="21" name="Прямокутник 20">
+            <a:extLst>
+              <a:ext uri="{FF2B5EF4-FFF2-40B4-BE49-F238E27FC236}">
+                <a16:creationId xmlns:a16="http://schemas.microsoft.com/office/drawing/2014/main" id="{5BDFD734-B7FA-80E7-4DFB-D2B80BF97973}"/>
+              </a:ext>
+            </a:extLst>
+          </p:cNvPr>
+          <p:cNvSpPr/>
+          <p:nvPr userDrawn="1"/>
+        </p:nvSpPr>
+        <p:spPr>
+          <a:xfrm>
+            <a:off x="7023600" y="4190400"/>
+            <a:ext cx="327600" cy="327600"/>
+          </a:xfrm>
+          <a:prstGeom prst="rect">
+            <a:avLst/>
+          </a:prstGeom>
+          <a:solidFill>
+            <a:srgbClr val="001319"/>
+          </a:solidFill>
+          <a:ln w="19050">
+            <a:solidFill>
+              <a:srgbClr val="C5923B"/>
+            </a:solidFill>
+          </a:ln>
+        </p:spPr>
+        <p:style>
+          <a:lnRef idx="2">
+            <a:schemeClr val="accent1">
+              <a:shade val="15000"/>
+            </a:schemeClr>
+          </a:lnRef>
+          <a:fillRef idx="1">
+            <a:schemeClr val="accent1"/>
+          </a:fillRef>
+          <a:effectRef idx="0">
+            <a:schemeClr val="accent1"/>
+          </a:effectRef>
+          <a:fontRef idx="minor">
+            <a:schemeClr val="lt1"/>
+          </a:fontRef>
+        </p:style>
+        <p:txBody>
+          <a:bodyPr rtlCol="0" anchor="ctr"/>
+          <a:lstStyle/>
+          <a:p>
+            <a:pPr algn="ctr"/>
+            <a:endParaRPr lang="ru-UA"/>
+          </a:p>
+        </p:txBody>
+      </p:sp>
     </p:spTree>
     <p:extLst>
       <p:ext uri="{BB962C8B-B14F-4D97-AF65-F5344CB8AC3E}">
@@ -1914,7 +2267,7 @@
 </p:sldLayout>
 </file>
 
-<file path=ppt/slideLayouts/slideLayout4.xml><?xml version="1.0" encoding="utf-8"?>
+<file path=ppt/slideLayouts/slideLayout5.xml><?xml version="1.0" encoding="utf-8"?>
 <p:sldLayout xmlns:a="http://schemas.openxmlformats.org/drawingml/2006/main" xmlns:r="http://schemas.openxmlformats.org/officeDocument/2006/relationships" xmlns:p="http://schemas.openxmlformats.org/presentationml/2006/main" preserve="1" userDrawn="1">
   <p:cSld name="PAGE_08_TRANSITION">
     <p:spTree>
@@ -2138,7 +2491,7 @@
 </p:sldLayout>
 </file>
 
-<file path=ppt/slideLayouts/slideLayout5.xml><?xml version="1.0" encoding="utf-8"?>
+<file path=ppt/slideLayouts/slideLayout6.xml><?xml version="1.0" encoding="utf-8"?>
 <p:sldLayout xmlns:a="http://schemas.openxmlformats.org/drawingml/2006/main" xmlns:r="http://schemas.openxmlformats.org/officeDocument/2006/relationships" xmlns:p="http://schemas.openxmlformats.org/presentationml/2006/main" preserve="1" userDrawn="1">
   <p:cSld name="PAGE_05_USER_FLOW">
     <p:spTree>
@@ -2809,9 +3162,9 @@
 </p:sldLayout>
 </file>
 
-<file path=ppt/slideLayouts/slideLayout6.xml><?xml version="1.0" encoding="utf-8"?>
+<file path=ppt/slideLayouts/slideLayout7.xml><?xml version="1.0" encoding="utf-8"?>
 <p:sldLayout xmlns:a="http://schemas.openxmlformats.org/drawingml/2006/main" xmlns:r="http://schemas.openxmlformats.org/officeDocument/2006/relationships" xmlns:p="http://schemas.openxmlformats.org/presentationml/2006/main" preserve="1" userDrawn="1">
-  <p:cSld name="Користувацький макет">
+  <p:cSld name="PAGE_06_LOCAL_MOTIFS">
     <p:spTree>
       <p:nvGrpSpPr>
         <p:cNvPr id="1" name=""/>
@@ -2828,70 +3181,10 @@
       </p:grpSpPr>
       <p:sp>
         <p:nvSpPr>
-          <p:cNvPr id="7" name="IMG_THEME_WORLD_PHOTO_1">
-            <a:extLst>
-              <a:ext uri="{FF2B5EF4-FFF2-40B4-BE49-F238E27FC236}">
-                <a16:creationId xmlns:a16="http://schemas.microsoft.com/office/drawing/2014/main" id="{A6FCE4D9-629C-457C-28F0-2B2323690539}"/>
-              </a:ext>
-            </a:extLst>
-          </p:cNvPr>
-          <p:cNvSpPr>
-            <a:spLocks noGrp="1"/>
-          </p:cNvSpPr>
-          <p:nvPr>
-            <p:ph type="pic" sz="quarter" idx="10"/>
-          </p:nvPr>
-        </p:nvSpPr>
-        <p:spPr>
-          <a:xfrm>
-            <a:off x="0" y="-1"/>
-            <a:ext cx="6094800" cy="6858000"/>
-          </a:xfrm>
-        </p:spPr>
-        <p:txBody>
-          <a:bodyPr/>
-          <a:lstStyle/>
-          <a:p>
-            <a:endParaRPr lang="ru-UA"/>
-          </a:p>
-        </p:txBody>
-      </p:sp>
-      <p:sp>
-        <p:nvSpPr>
-          <p:cNvPr id="9" name="IMG_THEME_WORLD_PHOTO_2">
-            <a:extLst>
-              <a:ext uri="{FF2B5EF4-FFF2-40B4-BE49-F238E27FC236}">
-                <a16:creationId xmlns:a16="http://schemas.microsoft.com/office/drawing/2014/main" id="{355E0EDF-FAA7-B038-2D55-A18F6454E794}"/>
-              </a:ext>
-            </a:extLst>
-          </p:cNvPr>
-          <p:cNvSpPr>
-            <a:spLocks noGrp="1"/>
-          </p:cNvSpPr>
-          <p:nvPr>
-            <p:ph type="pic" sz="quarter" idx="11"/>
-          </p:nvPr>
-        </p:nvSpPr>
-        <p:spPr>
-          <a:xfrm>
-            <a:off x="6094800" y="-1"/>
-            <a:ext cx="6094800" cy="6858000"/>
-          </a:xfrm>
-        </p:spPr>
-        <p:txBody>
-          <a:bodyPr/>
-          <a:lstStyle/>
-          <a:p>
-            <a:endParaRPr lang="ru-UA"/>
-          </a:p>
-        </p:txBody>
-      </p:sp>
-      <p:sp>
-        <p:nvSpPr>
-          <p:cNvPr id="13" name="Прямокутник 12">
-            <a:extLst>
-              <a:ext uri="{FF2B5EF4-FFF2-40B4-BE49-F238E27FC236}">
-                <a16:creationId xmlns:a16="http://schemas.microsoft.com/office/drawing/2014/main" id="{51459395-9D7C-2DB4-0DB1-E623660D2896}"/>
+          <p:cNvPr id="6" name="Овал 5">
+            <a:extLst>
+              <a:ext uri="{FF2B5EF4-FFF2-40B4-BE49-F238E27FC236}">
+                <a16:creationId xmlns:a16="http://schemas.microsoft.com/office/drawing/2014/main" id="{E74BA703-0345-E1A5-C438-4FD6358C09A0}"/>
               </a:ext>
             </a:extLst>
           </p:cNvPr>
@@ -2900,20 +3193,19 @@
         </p:nvSpPr>
         <p:spPr>
           <a:xfrm>
-            <a:off x="262799" y="273600"/>
-            <a:ext cx="3934800" cy="676800"/>
-          </a:xfrm>
-          <a:prstGeom prst="rect">
+            <a:off x="810000" y="2433600"/>
+            <a:ext cx="399600" cy="399600"/>
+          </a:xfrm>
+          <a:prstGeom prst="ellipse">
             <a:avLst/>
           </a:prstGeom>
           <a:solidFill>
-            <a:schemeClr val="bg1">
-              <a:lumMod val="10000"/>
-              <a:alpha val="60000"/>
-            </a:schemeClr>
+            <a:srgbClr val="001319"/>
           </a:solidFill>
-          <a:ln>
-            <a:noFill/>
+          <a:ln w="19050">
+            <a:solidFill>
+              <a:srgbClr val="C5923B"/>
+            </a:solidFill>
           </a:ln>
         </p:spPr>
         <p:style>
@@ -2943,10 +3235,10 @@
       </p:sp>
       <p:sp>
         <p:nvSpPr>
-          <p:cNvPr id="14" name="Прямокутник 13">
-            <a:extLst>
-              <a:ext uri="{FF2B5EF4-FFF2-40B4-BE49-F238E27FC236}">
-                <a16:creationId xmlns:a16="http://schemas.microsoft.com/office/drawing/2014/main" id="{4568C7C3-A128-9C36-204A-1CF987F42DD2}"/>
+          <p:cNvPr id="7" name="Овал 6">
+            <a:extLst>
+              <a:ext uri="{FF2B5EF4-FFF2-40B4-BE49-F238E27FC236}">
+                <a16:creationId xmlns:a16="http://schemas.microsoft.com/office/drawing/2014/main" id="{0DE5898A-E587-9513-0366-7F82312D19CF}"/>
               </a:ext>
             </a:extLst>
           </p:cNvPr>
@@ -2955,20 +3247,19 @@
         </p:nvSpPr>
         <p:spPr>
           <a:xfrm>
-            <a:off x="6357600" y="273600"/>
-            <a:ext cx="3934800" cy="676800"/>
-          </a:xfrm>
-          <a:prstGeom prst="rect">
+            <a:off x="810000" y="3776400"/>
+            <a:ext cx="399600" cy="399600"/>
+          </a:xfrm>
+          <a:prstGeom prst="ellipse">
             <a:avLst/>
           </a:prstGeom>
           <a:solidFill>
-            <a:schemeClr val="bg1">
-              <a:lumMod val="10000"/>
-              <a:alpha val="60000"/>
-            </a:schemeClr>
+            <a:srgbClr val="001319"/>
           </a:solidFill>
-          <a:ln>
-            <a:noFill/>
+          <a:ln w="19050">
+            <a:solidFill>
+              <a:srgbClr val="C5923B"/>
+            </a:solidFill>
           </a:ln>
         </p:spPr>
         <p:style>
@@ -2998,190 +3289,10 @@
       </p:sp>
       <p:sp>
         <p:nvSpPr>
-          <p:cNvPr id="11" name="TXT_THEME_WORLD_NAME_1">
-            <a:extLst>
-              <a:ext uri="{FF2B5EF4-FFF2-40B4-BE49-F238E27FC236}">
-                <a16:creationId xmlns:a16="http://schemas.microsoft.com/office/drawing/2014/main" id="{2850ECA9-D7FE-0421-B08C-1502F74F816D}"/>
-              </a:ext>
-            </a:extLst>
-          </p:cNvPr>
-          <p:cNvSpPr>
-            <a:spLocks noGrp="1"/>
-          </p:cNvSpPr>
-          <p:nvPr>
-            <p:ph type="body" sz="quarter" idx="12"/>
-          </p:nvPr>
-        </p:nvSpPr>
-        <p:spPr>
-          <a:xfrm>
-            <a:off x="511199" y="396000"/>
-            <a:ext cx="3420000" cy="374400"/>
-          </a:xfrm>
-        </p:spPr>
-        <p:txBody>
-          <a:bodyPr/>
-          <a:lstStyle>
-            <a:lvl1pPr>
-              <a:buNone/>
-              <a:defRPr sz="2741" baseline="0">
-                <a:solidFill>
-                  <a:srgbClr val="F2F0EE"/>
-                </a:solidFill>
-              </a:defRPr>
-            </a:lvl1pPr>
-            <a:lvl2pPr>
-              <a:buNone/>
-              <a:defRPr sz="2741" baseline="0">
-                <a:solidFill>
-                  <a:srgbClr val="F2F0EE"/>
-                </a:solidFill>
-              </a:defRPr>
-            </a:lvl2pPr>
-            <a:lvl3pPr>
-              <a:buNone/>
-              <a:defRPr sz="2741" baseline="0">
-                <a:solidFill>
-                  <a:srgbClr val="F2F0EE"/>
-                </a:solidFill>
-              </a:defRPr>
-            </a:lvl3pPr>
-            <a:lvl4pPr>
-              <a:buNone/>
-              <a:defRPr sz="2741" baseline="0">
-                <a:solidFill>
-                  <a:srgbClr val="F2F0EE"/>
-                </a:solidFill>
-              </a:defRPr>
-            </a:lvl4pPr>
-            <a:lvl5pPr>
-              <a:buNone/>
-              <a:defRPr sz="2741" baseline="0">
-                <a:solidFill>
-                  <a:srgbClr val="F2F0EE"/>
-                </a:solidFill>
-              </a:defRPr>
-            </a:lvl5pPr>
-          </a:lstStyle>
-          <a:p>
-            <a:pPr lvl="0"/>
-            <a:r>
-              <a:rPr lang="uk-UA" dirty="0"/>
-              <a:t>Клацніть</a:t>
-            </a:r>
-          </a:p>
-        </p:txBody>
-      </p:sp>
-      <p:sp>
-        <p:nvSpPr>
-          <p:cNvPr id="12" name="TXT_THEME_WORLD_NAME_2">
-            <a:extLst>
-              <a:ext uri="{FF2B5EF4-FFF2-40B4-BE49-F238E27FC236}">
-                <a16:creationId xmlns:a16="http://schemas.microsoft.com/office/drawing/2014/main" id="{C0934698-967E-BA7B-8398-8BED3B57BA0F}"/>
-              </a:ext>
-            </a:extLst>
-          </p:cNvPr>
-          <p:cNvSpPr>
-            <a:spLocks noGrp="1"/>
-          </p:cNvSpPr>
-          <p:nvPr>
-            <p:ph type="body" sz="quarter" idx="13"/>
-          </p:nvPr>
-        </p:nvSpPr>
-        <p:spPr>
-          <a:xfrm>
-            <a:off x="6606000" y="396000"/>
-            <a:ext cx="3420000" cy="374400"/>
-          </a:xfrm>
-        </p:spPr>
-        <p:txBody>
-          <a:bodyPr/>
-          <a:lstStyle>
-            <a:lvl1pPr>
-              <a:buNone/>
-              <a:defRPr sz="2741" baseline="0">
-                <a:solidFill>
-                  <a:srgbClr val="F2F0EE"/>
-                </a:solidFill>
-              </a:defRPr>
-            </a:lvl1pPr>
-            <a:lvl2pPr>
-              <a:buNone/>
-              <a:defRPr sz="2741" baseline="0">
-                <a:solidFill>
-                  <a:srgbClr val="F2F0EE"/>
-                </a:solidFill>
-              </a:defRPr>
-            </a:lvl2pPr>
-            <a:lvl3pPr>
-              <a:buNone/>
-              <a:defRPr sz="2741" baseline="0">
-                <a:solidFill>
-                  <a:srgbClr val="F2F0EE"/>
-                </a:solidFill>
-              </a:defRPr>
-            </a:lvl3pPr>
-            <a:lvl4pPr>
-              <a:buNone/>
-              <a:defRPr sz="2741" baseline="0">
-                <a:solidFill>
-                  <a:srgbClr val="F2F0EE"/>
-                </a:solidFill>
-              </a:defRPr>
-            </a:lvl4pPr>
-            <a:lvl5pPr>
-              <a:buNone/>
-              <a:defRPr sz="2741" baseline="0">
-                <a:solidFill>
-                  <a:srgbClr val="F2F0EE"/>
-                </a:solidFill>
-              </a:defRPr>
-            </a:lvl5pPr>
-          </a:lstStyle>
-          <a:p>
-            <a:pPr lvl="0"/>
-            <a:r>
-              <a:rPr lang="uk-UA" dirty="0"/>
-              <a:t>Клацніть</a:t>
-            </a:r>
-          </a:p>
-        </p:txBody>
-      </p:sp>
-    </p:spTree>
-    <p:extLst>
-      <p:ext uri="{BB962C8B-B14F-4D97-AF65-F5344CB8AC3E}">
-        <p14:creationId xmlns:p14="http://schemas.microsoft.com/office/powerpoint/2010/main" val="3346131210"/>
-      </p:ext>
-    </p:extLst>
-  </p:cSld>
-  <p:clrMapOvr>
-    <a:masterClrMapping/>
-  </p:clrMapOvr>
-</p:sldLayout>
-</file>
-
-<file path=ppt/slideLayouts/slideLayout7.xml><?xml version="1.0" encoding="utf-8"?>
-<p:sldLayout xmlns:a="http://schemas.openxmlformats.org/drawingml/2006/main" xmlns:r="http://schemas.openxmlformats.org/officeDocument/2006/relationships" xmlns:p="http://schemas.openxmlformats.org/presentationml/2006/main" preserve="1" userDrawn="1">
-  <p:cSld name="1_Користувацький макет">
-    <p:spTree>
-      <p:nvGrpSpPr>
-        <p:cNvPr id="1" name=""/>
-        <p:cNvGrpSpPr/>
-        <p:nvPr/>
-      </p:nvGrpSpPr>
-      <p:grpSpPr>
-        <a:xfrm>
-          <a:off x="0" y="0"/>
-          <a:ext cx="0" cy="0"/>
-          <a:chOff x="0" y="0"/>
-          <a:chExt cx="0" cy="0"/>
-        </a:xfrm>
-      </p:grpSpPr>
-      <p:sp>
-        <p:nvSpPr>
-          <p:cNvPr id="6" name="Овал 5">
-            <a:extLst>
-              <a:ext uri="{FF2B5EF4-FFF2-40B4-BE49-F238E27FC236}">
-                <a16:creationId xmlns:a16="http://schemas.microsoft.com/office/drawing/2014/main" id="{E74BA703-0345-E1A5-C438-4FD6358C09A0}"/>
+          <p:cNvPr id="8" name="Овал 7">
+            <a:extLst>
+              <a:ext uri="{FF2B5EF4-FFF2-40B4-BE49-F238E27FC236}">
+                <a16:creationId xmlns:a16="http://schemas.microsoft.com/office/drawing/2014/main" id="{B1F46F6E-A12D-3B1B-16F1-E4B304EFA6C5}"/>
               </a:ext>
             </a:extLst>
           </p:cNvPr>
@@ -3190,7 +3301,7 @@
         </p:nvSpPr>
         <p:spPr>
           <a:xfrm>
-            <a:off x="810000" y="2433600"/>
+            <a:off x="810000" y="5025600"/>
             <a:ext cx="399600" cy="399600"/>
           </a:xfrm>
           <a:prstGeom prst="ellipse">
@@ -3232,10 +3343,10 @@
       </p:sp>
       <p:sp>
         <p:nvSpPr>
-          <p:cNvPr id="7" name="Овал 6">
-            <a:extLst>
-              <a:ext uri="{FF2B5EF4-FFF2-40B4-BE49-F238E27FC236}">
-                <a16:creationId xmlns:a16="http://schemas.microsoft.com/office/drawing/2014/main" id="{0DE5898A-E587-9513-0366-7F82312D19CF}"/>
+          <p:cNvPr id="9" name="Прямокутник 8">
+            <a:extLst>
+              <a:ext uri="{FF2B5EF4-FFF2-40B4-BE49-F238E27FC236}">
+                <a16:creationId xmlns:a16="http://schemas.microsoft.com/office/drawing/2014/main" id="{DC43FDCC-3711-7C9A-89D0-597FAB6EBD05}"/>
               </a:ext>
             </a:extLst>
           </p:cNvPr>
@@ -3244,16 +3355,16 @@
         </p:nvSpPr>
         <p:spPr>
           <a:xfrm>
-            <a:off x="810000" y="3776400"/>
-            <a:ext cx="399600" cy="399600"/>
-          </a:xfrm>
-          <a:prstGeom prst="ellipse">
+            <a:off x="1126800" y="6170400"/>
+            <a:ext cx="6296400" cy="500400"/>
+          </a:xfrm>
+          <a:prstGeom prst="rect">
             <a:avLst/>
           </a:prstGeom>
           <a:solidFill>
-            <a:srgbClr val="001319"/>
+            <a:srgbClr val="001518"/>
           </a:solidFill>
-          <a:ln w="19050">
+          <a:ln>
             <a:solidFill>
               <a:srgbClr val="C5923B"/>
             </a:solidFill>
@@ -3286,10 +3397,1534 @@
       </p:sp>
       <p:sp>
         <p:nvSpPr>
-          <p:cNvPr id="8" name="Овал 7">
-            <a:extLst>
-              <a:ext uri="{FF2B5EF4-FFF2-40B4-BE49-F238E27FC236}">
-                <a16:creationId xmlns:a16="http://schemas.microsoft.com/office/drawing/2014/main" id="{B1F46F6E-A12D-3B1B-16F1-E4B304EFA6C5}"/>
+          <p:cNvPr id="11" name="TXT_MOTIF_HEADLINE">
+            <a:extLst>
+              <a:ext uri="{FF2B5EF4-FFF2-40B4-BE49-F238E27FC236}">
+                <a16:creationId xmlns:a16="http://schemas.microsoft.com/office/drawing/2014/main" id="{36C30D00-93A3-4E22-8A60-31A066430BCE}"/>
+              </a:ext>
+            </a:extLst>
+          </p:cNvPr>
+          <p:cNvSpPr>
+            <a:spLocks noGrp="1"/>
+          </p:cNvSpPr>
+          <p:nvPr>
+            <p:ph type="body" sz="quarter" idx="10"/>
+          </p:nvPr>
+        </p:nvSpPr>
+        <p:spPr>
+          <a:xfrm>
+            <a:off x="482400" y="367200"/>
+            <a:ext cx="4658400" cy="687600"/>
+          </a:xfrm>
+        </p:spPr>
+        <p:txBody>
+          <a:bodyPr/>
+          <a:lstStyle>
+            <a:lvl1pPr>
+              <a:buNone/>
+              <a:defRPr sz="2480" baseline="0">
+                <a:solidFill>
+                  <a:srgbClr val="231F20"/>
+                </a:solidFill>
+              </a:defRPr>
+            </a:lvl1pPr>
+            <a:lvl2pPr>
+              <a:buNone/>
+              <a:defRPr sz="2480" baseline="0">
+                <a:solidFill>
+                  <a:srgbClr val="231F20"/>
+                </a:solidFill>
+              </a:defRPr>
+            </a:lvl2pPr>
+            <a:lvl3pPr>
+              <a:buNone/>
+              <a:defRPr sz="2480" baseline="0">
+                <a:solidFill>
+                  <a:srgbClr val="231F20"/>
+                </a:solidFill>
+              </a:defRPr>
+            </a:lvl3pPr>
+            <a:lvl4pPr>
+              <a:buNone/>
+              <a:defRPr sz="2480" baseline="0">
+                <a:solidFill>
+                  <a:srgbClr val="231F20"/>
+                </a:solidFill>
+              </a:defRPr>
+            </a:lvl4pPr>
+            <a:lvl5pPr>
+              <a:buNone/>
+              <a:defRPr sz="2480" baseline="0">
+                <a:solidFill>
+                  <a:srgbClr val="231F20"/>
+                </a:solidFill>
+              </a:defRPr>
+            </a:lvl5pPr>
+          </a:lstStyle>
+          <a:p>
+            <a:pPr lvl="0"/>
+            <a:r>
+              <a:rPr lang="uk-UA" dirty="0"/>
+              <a:t>Клацніть, щоб відредагувати стилі зразків тексту</a:t>
+            </a:r>
+          </a:p>
+        </p:txBody>
+      </p:sp>
+      <p:sp>
+        <p:nvSpPr>
+          <p:cNvPr id="13" name="TXT_MOTIF_SUBHEADLINE">
+            <a:extLst>
+              <a:ext uri="{FF2B5EF4-FFF2-40B4-BE49-F238E27FC236}">
+                <a16:creationId xmlns:a16="http://schemas.microsoft.com/office/drawing/2014/main" id="{FC617ACC-84D0-4AF4-0FC6-7A6936FC25C5}"/>
+              </a:ext>
+            </a:extLst>
+          </p:cNvPr>
+          <p:cNvSpPr>
+            <a:spLocks noGrp="1"/>
+          </p:cNvSpPr>
+          <p:nvPr>
+            <p:ph type="body" sz="quarter" idx="11"/>
+          </p:nvPr>
+        </p:nvSpPr>
+        <p:spPr>
+          <a:xfrm>
+            <a:off x="511200" y="1335600"/>
+            <a:ext cx="3715200" cy="345600"/>
+          </a:xfrm>
+        </p:spPr>
+        <p:txBody>
+          <a:bodyPr/>
+          <a:lstStyle>
+            <a:lvl1pPr>
+              <a:buNone/>
+              <a:defRPr sz="1113" baseline="0">
+                <a:solidFill>
+                  <a:srgbClr val="231F20"/>
+                </a:solidFill>
+                <a:latin typeface="Myriad Pro" panose="020B0503030403020204" pitchFamily="34" charset="0"/>
+              </a:defRPr>
+            </a:lvl1pPr>
+            <a:lvl2pPr>
+              <a:buNone/>
+              <a:defRPr sz="1113" baseline="0">
+                <a:solidFill>
+                  <a:srgbClr val="231F20"/>
+                </a:solidFill>
+                <a:latin typeface="Myriad Pro" panose="020B0503030403020204" pitchFamily="34" charset="0"/>
+              </a:defRPr>
+            </a:lvl2pPr>
+            <a:lvl3pPr>
+              <a:buNone/>
+              <a:defRPr sz="1113" baseline="0">
+                <a:solidFill>
+                  <a:srgbClr val="231F20"/>
+                </a:solidFill>
+                <a:latin typeface="Myriad Pro" panose="020B0503030403020204" pitchFamily="34" charset="0"/>
+              </a:defRPr>
+            </a:lvl3pPr>
+            <a:lvl4pPr>
+              <a:buNone/>
+              <a:defRPr sz="1113" baseline="0">
+                <a:solidFill>
+                  <a:srgbClr val="231F20"/>
+                </a:solidFill>
+                <a:latin typeface="Myriad Pro" panose="020B0503030403020204" pitchFamily="34" charset="0"/>
+              </a:defRPr>
+            </a:lvl4pPr>
+            <a:lvl5pPr>
+              <a:buNone/>
+              <a:defRPr sz="1113" baseline="0">
+                <a:solidFill>
+                  <a:srgbClr val="231F20"/>
+                </a:solidFill>
+                <a:latin typeface="Myriad Pro" panose="020B0503030403020204" pitchFamily="34" charset="0"/>
+              </a:defRPr>
+            </a:lvl5pPr>
+          </a:lstStyle>
+          <a:p>
+            <a:pPr lvl="0"/>
+            <a:r>
+              <a:rPr lang="uk-UA" dirty="0"/>
+              <a:t>Клацніть, щоб відредагувати стилі зразків тексту</a:t>
+            </a:r>
+            <a:endParaRPr lang="ru-UA" dirty="0"/>
+          </a:p>
+        </p:txBody>
+      </p:sp>
+      <p:sp>
+        <p:nvSpPr>
+          <p:cNvPr id="15" name="TXT_THEME_WORLD_NAME">
+            <a:extLst>
+              <a:ext uri="{FF2B5EF4-FFF2-40B4-BE49-F238E27FC236}">
+                <a16:creationId xmlns:a16="http://schemas.microsoft.com/office/drawing/2014/main" id="{5D94B055-A168-5625-12D4-2D458A552309}"/>
+              </a:ext>
+            </a:extLst>
+          </p:cNvPr>
+          <p:cNvSpPr>
+            <a:spLocks noGrp="1"/>
+          </p:cNvSpPr>
+          <p:nvPr>
+            <p:ph type="body" sz="quarter" idx="12"/>
+          </p:nvPr>
+        </p:nvSpPr>
+        <p:spPr>
+          <a:xfrm>
+            <a:off x="511199" y="1742400"/>
+            <a:ext cx="5400000" cy="194400"/>
+          </a:xfrm>
+        </p:spPr>
+        <p:txBody>
+          <a:bodyPr/>
+          <a:lstStyle>
+            <a:lvl1pPr>
+              <a:buNone/>
+              <a:defRPr sz="1430" baseline="0">
+                <a:solidFill>
+                  <a:srgbClr val="231F20"/>
+                </a:solidFill>
+              </a:defRPr>
+            </a:lvl1pPr>
+            <a:lvl2pPr>
+              <a:buNone/>
+              <a:defRPr sz="1430" baseline="0">
+                <a:solidFill>
+                  <a:srgbClr val="231F20"/>
+                </a:solidFill>
+              </a:defRPr>
+            </a:lvl2pPr>
+            <a:lvl3pPr>
+              <a:buNone/>
+              <a:defRPr sz="1430" baseline="0">
+                <a:solidFill>
+                  <a:srgbClr val="231F20"/>
+                </a:solidFill>
+              </a:defRPr>
+            </a:lvl3pPr>
+            <a:lvl4pPr>
+              <a:buNone/>
+              <a:defRPr sz="1430" baseline="0">
+                <a:solidFill>
+                  <a:srgbClr val="231F20"/>
+                </a:solidFill>
+              </a:defRPr>
+            </a:lvl4pPr>
+            <a:lvl5pPr>
+              <a:buNone/>
+              <a:defRPr sz="1430" baseline="0">
+                <a:solidFill>
+                  <a:srgbClr val="231F20"/>
+                </a:solidFill>
+              </a:defRPr>
+            </a:lvl5pPr>
+          </a:lstStyle>
+          <a:p>
+            <a:pPr lvl="0"/>
+            <a:r>
+              <a:rPr lang="uk-UA" dirty="0"/>
+              <a:t>Клацніть, щоб відредагувати стилі зразків тексту</a:t>
+            </a:r>
+          </a:p>
+        </p:txBody>
+      </p:sp>
+      <p:sp>
+        <p:nvSpPr>
+          <p:cNvPr id="17" name="TXT_MOTIF_COLUMN_HEADER_1">
+            <a:extLst>
+              <a:ext uri="{FF2B5EF4-FFF2-40B4-BE49-F238E27FC236}">
+                <a16:creationId xmlns:a16="http://schemas.microsoft.com/office/drawing/2014/main" id="{F10BC6DA-36B3-B4E5-680F-6924CD22C7E4}"/>
+              </a:ext>
+            </a:extLst>
+          </p:cNvPr>
+          <p:cNvSpPr>
+            <a:spLocks noGrp="1"/>
+          </p:cNvSpPr>
+          <p:nvPr>
+            <p:ph type="body" sz="quarter" idx="13"/>
+          </p:nvPr>
+        </p:nvSpPr>
+        <p:spPr>
+          <a:xfrm>
+            <a:off x="3052800" y="2059200"/>
+            <a:ext cx="597600" cy="187200"/>
+          </a:xfrm>
+        </p:spPr>
+        <p:txBody>
+          <a:bodyPr/>
+          <a:lstStyle>
+            <a:lvl1pPr>
+              <a:buNone/>
+              <a:defRPr sz="1170" baseline="0">
+                <a:solidFill>
+                  <a:srgbClr val="231F20"/>
+                </a:solidFill>
+                <a:latin typeface="Myriad Pro" panose="020B0503030403020204" pitchFamily="34" charset="0"/>
+              </a:defRPr>
+            </a:lvl1pPr>
+          </a:lstStyle>
+          <a:p>
+            <a:pPr lvl="0"/>
+            <a:r>
+              <a:rPr lang="uk-UA" dirty="0" err="1"/>
+              <a:t>Клац</a:t>
+            </a:r>
+            <a:endParaRPr lang="uk-UA" dirty="0"/>
+          </a:p>
+          <a:p>
+            <a:pPr lvl="0"/>
+            <a:endParaRPr lang="ru-UA" dirty="0"/>
+          </a:p>
+        </p:txBody>
+      </p:sp>
+      <p:sp>
+        <p:nvSpPr>
+          <p:cNvPr id="19" name="TXT_MOTIF_COLUMN_HEADER_23">
+            <a:extLst>
+              <a:ext uri="{FF2B5EF4-FFF2-40B4-BE49-F238E27FC236}">
+                <a16:creationId xmlns:a16="http://schemas.microsoft.com/office/drawing/2014/main" id="{4B4B0961-A4F9-7785-EEB8-D9FEDA9D9282}"/>
+              </a:ext>
+            </a:extLst>
+          </p:cNvPr>
+          <p:cNvSpPr>
+            <a:spLocks noGrp="1"/>
+          </p:cNvSpPr>
+          <p:nvPr>
+            <p:ph type="body" sz="quarter" idx="14"/>
+          </p:nvPr>
+        </p:nvSpPr>
+        <p:spPr>
+          <a:xfrm>
+            <a:off x="5864399" y="2041200"/>
+            <a:ext cx="2916000" cy="187200"/>
+          </a:xfrm>
+        </p:spPr>
+        <p:txBody>
+          <a:bodyPr/>
+          <a:lstStyle>
+            <a:lvl1pPr>
+              <a:buNone/>
+              <a:defRPr sz="1180" baseline="0">
+                <a:solidFill>
+                  <a:srgbClr val="231F20"/>
+                </a:solidFill>
+                <a:latin typeface="Myriad Pro" panose="020B0503030403020204" pitchFamily="34" charset="0"/>
+              </a:defRPr>
+            </a:lvl1pPr>
+            <a:lvl2pPr>
+              <a:buNone/>
+              <a:defRPr sz="1180" baseline="0">
+                <a:solidFill>
+                  <a:srgbClr val="231F20"/>
+                </a:solidFill>
+                <a:latin typeface="Myriad Pro" panose="020B0503030403020204" pitchFamily="34" charset="0"/>
+              </a:defRPr>
+            </a:lvl2pPr>
+            <a:lvl3pPr>
+              <a:buNone/>
+              <a:defRPr sz="1180" baseline="0">
+                <a:solidFill>
+                  <a:srgbClr val="231F20"/>
+                </a:solidFill>
+                <a:latin typeface="Myriad Pro" panose="020B0503030403020204" pitchFamily="34" charset="0"/>
+              </a:defRPr>
+            </a:lvl3pPr>
+            <a:lvl4pPr>
+              <a:buNone/>
+              <a:defRPr sz="1180" baseline="0">
+                <a:solidFill>
+                  <a:srgbClr val="231F20"/>
+                </a:solidFill>
+                <a:latin typeface="Myriad Pro" panose="020B0503030403020204" pitchFamily="34" charset="0"/>
+              </a:defRPr>
+            </a:lvl4pPr>
+            <a:lvl5pPr>
+              <a:buNone/>
+              <a:defRPr sz="1180" baseline="0">
+                <a:solidFill>
+                  <a:srgbClr val="231F20"/>
+                </a:solidFill>
+                <a:latin typeface="Myriad Pro" panose="020B0503030403020204" pitchFamily="34" charset="0"/>
+              </a:defRPr>
+            </a:lvl5pPr>
+          </a:lstStyle>
+          <a:p>
+            <a:pPr lvl="0"/>
+            <a:r>
+              <a:rPr lang="uk-UA" dirty="0"/>
+              <a:t>Клацніть</a:t>
+            </a:r>
+            <a:endParaRPr lang="en-US" dirty="0"/>
+          </a:p>
+          <a:p>
+            <a:pPr lvl="0"/>
+            <a:endParaRPr lang="ru-UA" dirty="0"/>
+          </a:p>
+        </p:txBody>
+      </p:sp>
+      <p:sp>
+        <p:nvSpPr>
+          <p:cNvPr id="21" name="TXT_MOTIF_ROW_NUMBER_1">
+            <a:extLst>
+              <a:ext uri="{FF2B5EF4-FFF2-40B4-BE49-F238E27FC236}">
+                <a16:creationId xmlns:a16="http://schemas.microsoft.com/office/drawing/2014/main" id="{A1AAAA45-CD44-4FEE-BF56-C8ECDA18D445}"/>
+              </a:ext>
+            </a:extLst>
+          </p:cNvPr>
+          <p:cNvSpPr txBox="1"/>
+          <p:nvPr userDrawn="1"/>
+        </p:nvSpPr>
+        <p:spPr>
+          <a:xfrm>
+            <a:off x="925200" y="2455200"/>
+            <a:ext cx="176400" cy="437043"/>
+          </a:xfrm>
+          <a:prstGeom prst="rect">
+            <a:avLst/>
+          </a:prstGeom>
+          <a:noFill/>
+        </p:spPr>
+        <p:txBody>
+          <a:bodyPr wrap="square" rtlCol="0">
+            <a:spAutoFit/>
+          </a:bodyPr>
+          <a:lstStyle/>
+          <a:p>
+            <a:r>
+              <a:rPr lang="en-US" sz="2240" baseline="0" dirty="0">
+                <a:solidFill>
+                  <a:srgbClr val="C5923B"/>
+                </a:solidFill>
+                <a:latin typeface="Core Serif N 75 Black" panose="02020504080301010804" pitchFamily="18"/>
+              </a:rPr>
+              <a:t>1</a:t>
+            </a:r>
+            <a:endParaRPr lang="ru-UA" sz="2240" baseline="0" dirty="0">
+              <a:solidFill>
+                <a:srgbClr val="C5923B"/>
+              </a:solidFill>
+            </a:endParaRPr>
+          </a:p>
+        </p:txBody>
+      </p:sp>
+      <p:sp>
+        <p:nvSpPr>
+          <p:cNvPr id="22" name="TXT_MOTIF_ROW_NUMBER_2">
+            <a:extLst>
+              <a:ext uri="{FF2B5EF4-FFF2-40B4-BE49-F238E27FC236}">
+                <a16:creationId xmlns:a16="http://schemas.microsoft.com/office/drawing/2014/main" id="{CB1E552E-C499-44F7-6EF2-74CE56EFBF32}"/>
+              </a:ext>
+            </a:extLst>
+          </p:cNvPr>
+          <p:cNvSpPr txBox="1"/>
+          <p:nvPr userDrawn="1"/>
+        </p:nvSpPr>
+        <p:spPr>
+          <a:xfrm>
+            <a:off x="925200" y="3798000"/>
+            <a:ext cx="176400" cy="437043"/>
+          </a:xfrm>
+          <a:prstGeom prst="rect">
+            <a:avLst/>
+          </a:prstGeom>
+          <a:noFill/>
+        </p:spPr>
+        <p:txBody>
+          <a:bodyPr wrap="square" rtlCol="0">
+            <a:spAutoFit/>
+          </a:bodyPr>
+          <a:lstStyle/>
+          <a:p>
+            <a:r>
+              <a:rPr lang="uk-UA" sz="2240" baseline="0" dirty="0">
+                <a:solidFill>
+                  <a:srgbClr val="C5923B"/>
+                </a:solidFill>
+                <a:latin typeface="Core Serif N 75 Black" panose="02020504080301010804" pitchFamily="18"/>
+              </a:rPr>
+              <a:t>2</a:t>
+            </a:r>
+            <a:endParaRPr lang="ru-UA" sz="2240" baseline="0" dirty="0">
+              <a:solidFill>
+                <a:srgbClr val="C5923B"/>
+              </a:solidFill>
+            </a:endParaRPr>
+          </a:p>
+        </p:txBody>
+      </p:sp>
+      <p:sp>
+        <p:nvSpPr>
+          <p:cNvPr id="23" name="TXT_MOTIF_ROW_NUMBER_3">
+            <a:extLst>
+              <a:ext uri="{FF2B5EF4-FFF2-40B4-BE49-F238E27FC236}">
+                <a16:creationId xmlns:a16="http://schemas.microsoft.com/office/drawing/2014/main" id="{93D3648D-95D3-798E-B955-D3E2F2774187}"/>
+              </a:ext>
+            </a:extLst>
+          </p:cNvPr>
+          <p:cNvSpPr txBox="1"/>
+          <p:nvPr userDrawn="1"/>
+        </p:nvSpPr>
+        <p:spPr>
+          <a:xfrm>
+            <a:off x="925200" y="5047200"/>
+            <a:ext cx="176400" cy="437043"/>
+          </a:xfrm>
+          <a:prstGeom prst="rect">
+            <a:avLst/>
+          </a:prstGeom>
+          <a:noFill/>
+        </p:spPr>
+        <p:txBody>
+          <a:bodyPr wrap="square" rtlCol="0">
+            <a:spAutoFit/>
+          </a:bodyPr>
+          <a:lstStyle/>
+          <a:p>
+            <a:r>
+              <a:rPr lang="uk-UA" sz="2240" baseline="0" dirty="0">
+                <a:solidFill>
+                  <a:srgbClr val="C5923B"/>
+                </a:solidFill>
+                <a:latin typeface="Core Serif N 75 Black" panose="02020504080301010804" pitchFamily="18"/>
+              </a:rPr>
+              <a:t>3</a:t>
+            </a:r>
+            <a:endParaRPr lang="ru-UA" sz="2240" baseline="0" dirty="0">
+              <a:solidFill>
+                <a:srgbClr val="C5923B"/>
+              </a:solidFill>
+            </a:endParaRPr>
+          </a:p>
+        </p:txBody>
+      </p:sp>
+      <p:sp>
+        <p:nvSpPr>
+          <p:cNvPr id="25" name="TXT_MOTIF_3_NAME">
+            <a:extLst>
+              <a:ext uri="{FF2B5EF4-FFF2-40B4-BE49-F238E27FC236}">
+                <a16:creationId xmlns:a16="http://schemas.microsoft.com/office/drawing/2014/main" id="{C962E585-BC6A-437F-56ED-9EBF60285529}"/>
+              </a:ext>
+            </a:extLst>
+          </p:cNvPr>
+          <p:cNvSpPr>
+            <a:spLocks noGrp="1"/>
+          </p:cNvSpPr>
+          <p:nvPr>
+            <p:ph type="body" sz="quarter" idx="15"/>
+          </p:nvPr>
+        </p:nvSpPr>
+        <p:spPr>
+          <a:xfrm>
+            <a:off x="568800" y="2948400"/>
+            <a:ext cx="1044000" cy="255600"/>
+          </a:xfrm>
+        </p:spPr>
+        <p:txBody>
+          <a:bodyPr/>
+          <a:lstStyle>
+            <a:lvl1pPr>
+              <a:buNone/>
+              <a:defRPr sz="830" baseline="0">
+                <a:solidFill>
+                  <a:srgbClr val="231F20"/>
+                </a:solidFill>
+                <a:latin typeface="Myriad Pro" panose="020B0503030403020204" pitchFamily="34" charset="0"/>
+              </a:defRPr>
+            </a:lvl1pPr>
+            <a:lvl2pPr>
+              <a:buNone/>
+              <a:defRPr sz="830" baseline="0">
+                <a:solidFill>
+                  <a:srgbClr val="231F20"/>
+                </a:solidFill>
+                <a:latin typeface="Myriad Pro" panose="020B0503030403020204" pitchFamily="34" charset="0"/>
+              </a:defRPr>
+            </a:lvl2pPr>
+            <a:lvl3pPr>
+              <a:buNone/>
+              <a:defRPr sz="830" baseline="0">
+                <a:solidFill>
+                  <a:srgbClr val="231F20"/>
+                </a:solidFill>
+                <a:latin typeface="Myriad Pro" panose="020B0503030403020204" pitchFamily="34" charset="0"/>
+              </a:defRPr>
+            </a:lvl3pPr>
+            <a:lvl4pPr>
+              <a:buNone/>
+              <a:defRPr sz="830" baseline="0">
+                <a:solidFill>
+                  <a:srgbClr val="231F20"/>
+                </a:solidFill>
+                <a:latin typeface="Myriad Pro" panose="020B0503030403020204" pitchFamily="34" charset="0"/>
+              </a:defRPr>
+            </a:lvl4pPr>
+            <a:lvl5pPr>
+              <a:buNone/>
+              <a:defRPr sz="830" baseline="0">
+                <a:solidFill>
+                  <a:srgbClr val="231F20"/>
+                </a:solidFill>
+                <a:latin typeface="Myriad Pro" panose="020B0503030403020204" pitchFamily="34" charset="0"/>
+              </a:defRPr>
+            </a:lvl5pPr>
+          </a:lstStyle>
+          <a:p>
+            <a:pPr lvl="0"/>
+            <a:r>
+              <a:rPr lang="uk-UA" dirty="0"/>
+              <a:t>Клацніть,</a:t>
+            </a:r>
+            <a:endParaRPr lang="en-US" dirty="0"/>
+          </a:p>
+          <a:p>
+            <a:pPr lvl="0"/>
+            <a:endParaRPr lang="uk-UA" dirty="0"/>
+          </a:p>
+        </p:txBody>
+      </p:sp>
+      <p:sp>
+        <p:nvSpPr>
+          <p:cNvPr id="26" name="TXT_MOTIF_2_NAME">
+            <a:extLst>
+              <a:ext uri="{FF2B5EF4-FFF2-40B4-BE49-F238E27FC236}">
+                <a16:creationId xmlns:a16="http://schemas.microsoft.com/office/drawing/2014/main" id="{8D7654FD-3710-64A6-21C5-42749B6A42D9}"/>
+              </a:ext>
+            </a:extLst>
+          </p:cNvPr>
+          <p:cNvSpPr>
+            <a:spLocks noGrp="1"/>
+          </p:cNvSpPr>
+          <p:nvPr>
+            <p:ph type="body" sz="quarter" idx="16"/>
+          </p:nvPr>
+        </p:nvSpPr>
+        <p:spPr>
+          <a:xfrm>
+            <a:off x="568800" y="4266000"/>
+            <a:ext cx="1044000" cy="255600"/>
+          </a:xfrm>
+        </p:spPr>
+        <p:txBody>
+          <a:bodyPr/>
+          <a:lstStyle>
+            <a:lvl1pPr>
+              <a:buNone/>
+              <a:defRPr sz="830" baseline="0">
+                <a:solidFill>
+                  <a:srgbClr val="231F20"/>
+                </a:solidFill>
+                <a:latin typeface="Myriad Pro" panose="020B0503030403020204" pitchFamily="34" charset="0"/>
+              </a:defRPr>
+            </a:lvl1pPr>
+            <a:lvl2pPr>
+              <a:buNone/>
+              <a:defRPr sz="830" baseline="0">
+                <a:solidFill>
+                  <a:srgbClr val="231F20"/>
+                </a:solidFill>
+                <a:latin typeface="Myriad Pro" panose="020B0503030403020204" pitchFamily="34" charset="0"/>
+              </a:defRPr>
+            </a:lvl2pPr>
+            <a:lvl3pPr>
+              <a:buNone/>
+              <a:defRPr sz="830" baseline="0">
+                <a:solidFill>
+                  <a:srgbClr val="231F20"/>
+                </a:solidFill>
+                <a:latin typeface="Myriad Pro" panose="020B0503030403020204" pitchFamily="34" charset="0"/>
+              </a:defRPr>
+            </a:lvl3pPr>
+            <a:lvl4pPr>
+              <a:buNone/>
+              <a:defRPr sz="830" baseline="0">
+                <a:solidFill>
+                  <a:srgbClr val="231F20"/>
+                </a:solidFill>
+                <a:latin typeface="Myriad Pro" panose="020B0503030403020204" pitchFamily="34" charset="0"/>
+              </a:defRPr>
+            </a:lvl4pPr>
+            <a:lvl5pPr>
+              <a:buNone/>
+              <a:defRPr sz="830" baseline="0">
+                <a:solidFill>
+                  <a:srgbClr val="231F20"/>
+                </a:solidFill>
+                <a:latin typeface="Myriad Pro" panose="020B0503030403020204" pitchFamily="34" charset="0"/>
+              </a:defRPr>
+            </a:lvl5pPr>
+          </a:lstStyle>
+          <a:p>
+            <a:pPr lvl="0"/>
+            <a:r>
+              <a:rPr lang="uk-UA" dirty="0"/>
+              <a:t>Клацніть,</a:t>
+            </a:r>
+            <a:endParaRPr lang="en-US" dirty="0"/>
+          </a:p>
+          <a:p>
+            <a:pPr lvl="0"/>
+            <a:endParaRPr lang="uk-UA" dirty="0"/>
+          </a:p>
+        </p:txBody>
+      </p:sp>
+      <p:sp>
+        <p:nvSpPr>
+          <p:cNvPr id="27" name="TXT_MOTIF_1_NAME">
+            <a:extLst>
+              <a:ext uri="{FF2B5EF4-FFF2-40B4-BE49-F238E27FC236}">
+                <a16:creationId xmlns:a16="http://schemas.microsoft.com/office/drawing/2014/main" id="{7241013F-BB8B-DAFA-7457-EB1A73F821A9}"/>
+              </a:ext>
+            </a:extLst>
+          </p:cNvPr>
+          <p:cNvSpPr>
+            <a:spLocks noGrp="1"/>
+          </p:cNvSpPr>
+          <p:nvPr>
+            <p:ph type="body" sz="quarter" idx="17"/>
+          </p:nvPr>
+        </p:nvSpPr>
+        <p:spPr>
+          <a:xfrm>
+            <a:off x="568800" y="5522400"/>
+            <a:ext cx="1044000" cy="255600"/>
+          </a:xfrm>
+        </p:spPr>
+        <p:txBody>
+          <a:bodyPr/>
+          <a:lstStyle>
+            <a:lvl1pPr>
+              <a:buNone/>
+              <a:defRPr sz="830" baseline="0">
+                <a:solidFill>
+                  <a:srgbClr val="231F20"/>
+                </a:solidFill>
+                <a:latin typeface="Myriad Pro" panose="020B0503030403020204" pitchFamily="34" charset="0"/>
+              </a:defRPr>
+            </a:lvl1pPr>
+            <a:lvl2pPr>
+              <a:buNone/>
+              <a:defRPr sz="830" baseline="0">
+                <a:solidFill>
+                  <a:srgbClr val="231F20"/>
+                </a:solidFill>
+                <a:latin typeface="Myriad Pro" panose="020B0503030403020204" pitchFamily="34" charset="0"/>
+              </a:defRPr>
+            </a:lvl2pPr>
+            <a:lvl3pPr>
+              <a:buNone/>
+              <a:defRPr sz="830" baseline="0">
+                <a:solidFill>
+                  <a:srgbClr val="231F20"/>
+                </a:solidFill>
+                <a:latin typeface="Myriad Pro" panose="020B0503030403020204" pitchFamily="34" charset="0"/>
+              </a:defRPr>
+            </a:lvl3pPr>
+            <a:lvl4pPr>
+              <a:buNone/>
+              <a:defRPr sz="830" baseline="0">
+                <a:solidFill>
+                  <a:srgbClr val="231F20"/>
+                </a:solidFill>
+                <a:latin typeface="Myriad Pro" panose="020B0503030403020204" pitchFamily="34" charset="0"/>
+              </a:defRPr>
+            </a:lvl4pPr>
+            <a:lvl5pPr>
+              <a:buNone/>
+              <a:defRPr sz="830" baseline="0">
+                <a:solidFill>
+                  <a:srgbClr val="231F20"/>
+                </a:solidFill>
+                <a:latin typeface="Myriad Pro" panose="020B0503030403020204" pitchFamily="34" charset="0"/>
+              </a:defRPr>
+            </a:lvl5pPr>
+          </a:lstStyle>
+          <a:p>
+            <a:pPr lvl="0"/>
+            <a:r>
+              <a:rPr lang="uk-UA" dirty="0"/>
+              <a:t>Клацніть,</a:t>
+            </a:r>
+            <a:endParaRPr lang="en-US" dirty="0"/>
+          </a:p>
+          <a:p>
+            <a:pPr lvl="0"/>
+            <a:endParaRPr lang="uk-UA" dirty="0"/>
+          </a:p>
+        </p:txBody>
+      </p:sp>
+      <p:sp>
+        <p:nvSpPr>
+          <p:cNvPr id="29" name="TXT_MOTIF_STATS_CALLOUT">
+            <a:extLst>
+              <a:ext uri="{FF2B5EF4-FFF2-40B4-BE49-F238E27FC236}">
+                <a16:creationId xmlns:a16="http://schemas.microsoft.com/office/drawing/2014/main" id="{D343B36D-4567-682F-EB69-A9904C680CC9}"/>
+              </a:ext>
+            </a:extLst>
+          </p:cNvPr>
+          <p:cNvSpPr>
+            <a:spLocks noGrp="1"/>
+          </p:cNvSpPr>
+          <p:nvPr>
+            <p:ph type="body" sz="quarter" idx="18"/>
+          </p:nvPr>
+        </p:nvSpPr>
+        <p:spPr>
+          <a:xfrm>
+            <a:off x="2350799" y="6249599"/>
+            <a:ext cx="5036400" cy="370800"/>
+          </a:xfrm>
+        </p:spPr>
+        <p:txBody>
+          <a:bodyPr/>
+          <a:lstStyle>
+            <a:lvl1pPr>
+              <a:buNone/>
+              <a:defRPr sz="1180" baseline="0">
+                <a:solidFill>
+                  <a:srgbClr val="C5923B"/>
+                </a:solidFill>
+              </a:defRPr>
+            </a:lvl1pPr>
+            <a:lvl2pPr>
+              <a:buNone/>
+              <a:defRPr sz="1180" baseline="0">
+                <a:solidFill>
+                  <a:srgbClr val="C5923B"/>
+                </a:solidFill>
+              </a:defRPr>
+            </a:lvl2pPr>
+            <a:lvl3pPr>
+              <a:buNone/>
+              <a:defRPr sz="1180" baseline="0">
+                <a:solidFill>
+                  <a:srgbClr val="C5923B"/>
+                </a:solidFill>
+              </a:defRPr>
+            </a:lvl3pPr>
+            <a:lvl4pPr>
+              <a:buNone/>
+              <a:defRPr sz="1180" baseline="0">
+                <a:solidFill>
+                  <a:srgbClr val="C5923B"/>
+                </a:solidFill>
+              </a:defRPr>
+            </a:lvl4pPr>
+            <a:lvl5pPr>
+              <a:buNone/>
+              <a:defRPr sz="1180" baseline="0">
+                <a:solidFill>
+                  <a:srgbClr val="C5923B"/>
+                </a:solidFill>
+              </a:defRPr>
+            </a:lvl5pPr>
+          </a:lstStyle>
+          <a:p>
+            <a:pPr lvl="0"/>
+            <a:r>
+              <a:rPr lang="uk-UA" dirty="0"/>
+              <a:t>Клацніть, щоб відредагувати стилі зразків тексту</a:t>
+            </a:r>
+          </a:p>
+        </p:txBody>
+      </p:sp>
+      <p:sp>
+        <p:nvSpPr>
+          <p:cNvPr id="31" name="IMG_MOTIF_1_PHOTO">
+            <a:extLst>
+              <a:ext uri="{FF2B5EF4-FFF2-40B4-BE49-F238E27FC236}">
+                <a16:creationId xmlns:a16="http://schemas.microsoft.com/office/drawing/2014/main" id="{62B219E3-1E42-91D4-A426-7F00E974FDF9}"/>
+              </a:ext>
+            </a:extLst>
+          </p:cNvPr>
+          <p:cNvSpPr>
+            <a:spLocks noGrp="1"/>
+          </p:cNvSpPr>
+          <p:nvPr>
+            <p:ph type="pic" sz="quarter" idx="19"/>
+          </p:nvPr>
+        </p:nvSpPr>
+        <p:spPr>
+          <a:xfrm>
+            <a:off x="1457999" y="2152800"/>
+            <a:ext cx="2469600" cy="1389600"/>
+          </a:xfrm>
+        </p:spPr>
+        <p:txBody>
+          <a:bodyPr/>
+          <a:lstStyle/>
+          <a:p>
+            <a:endParaRPr lang="ru-UA"/>
+          </a:p>
+        </p:txBody>
+      </p:sp>
+      <p:sp>
+        <p:nvSpPr>
+          <p:cNvPr id="33" name="IMG_MOTIF_1_BACKGROUND">
+            <a:extLst>
+              <a:ext uri="{FF2B5EF4-FFF2-40B4-BE49-F238E27FC236}">
+                <a16:creationId xmlns:a16="http://schemas.microsoft.com/office/drawing/2014/main" id="{2D2D4949-E3F2-C23B-4310-445056A8B513}"/>
+              </a:ext>
+            </a:extLst>
+          </p:cNvPr>
+          <p:cNvSpPr>
+            <a:spLocks noGrp="1"/>
+          </p:cNvSpPr>
+          <p:nvPr>
+            <p:ph type="pic" sz="quarter" idx="20"/>
+          </p:nvPr>
+        </p:nvSpPr>
+        <p:spPr>
+          <a:xfrm>
+            <a:off x="4748400" y="2152800"/>
+            <a:ext cx="2469600" cy="1389600"/>
+          </a:xfrm>
+        </p:spPr>
+        <p:txBody>
+          <a:bodyPr/>
+          <a:lstStyle/>
+          <a:p>
+            <a:endParaRPr lang="ru-UA"/>
+          </a:p>
+        </p:txBody>
+      </p:sp>
+      <p:sp>
+        <p:nvSpPr>
+          <p:cNvPr id="35" name="IMG_MOTIF_1_MASK">
+            <a:extLst>
+              <a:ext uri="{FF2B5EF4-FFF2-40B4-BE49-F238E27FC236}">
+                <a16:creationId xmlns:a16="http://schemas.microsoft.com/office/drawing/2014/main" id="{8E098B13-ABE9-2F3F-C2D3-6B0A5A4B6274}"/>
+              </a:ext>
+            </a:extLst>
+          </p:cNvPr>
+          <p:cNvSpPr>
+            <a:spLocks noGrp="1"/>
+          </p:cNvSpPr>
+          <p:nvPr>
+            <p:ph type="pic" sz="quarter" idx="21"/>
+          </p:nvPr>
+        </p:nvSpPr>
+        <p:spPr>
+          <a:xfrm>
+            <a:off x="8038800" y="2152800"/>
+            <a:ext cx="2469600" cy="1389600"/>
+          </a:xfrm>
+        </p:spPr>
+        <p:txBody>
+          <a:bodyPr/>
+          <a:lstStyle/>
+          <a:p>
+            <a:endParaRPr lang="ru-UA"/>
+          </a:p>
+        </p:txBody>
+      </p:sp>
+      <p:sp>
+        <p:nvSpPr>
+          <p:cNvPr id="37" name="IMG_MOTIF_2_PHOTO">
+            <a:extLst>
+              <a:ext uri="{FF2B5EF4-FFF2-40B4-BE49-F238E27FC236}">
+                <a16:creationId xmlns:a16="http://schemas.microsoft.com/office/drawing/2014/main" id="{5DB5C86A-F711-1BC6-EFEB-670FEDE78127}"/>
+              </a:ext>
+            </a:extLst>
+          </p:cNvPr>
+          <p:cNvSpPr>
+            <a:spLocks noGrp="1"/>
+          </p:cNvSpPr>
+          <p:nvPr>
+            <p:ph type="pic" sz="quarter" idx="22"/>
+          </p:nvPr>
+        </p:nvSpPr>
+        <p:spPr>
+          <a:xfrm>
+            <a:off x="1457999" y="3542400"/>
+            <a:ext cx="2469600" cy="1389600"/>
+          </a:xfrm>
+        </p:spPr>
+        <p:txBody>
+          <a:bodyPr/>
+          <a:lstStyle/>
+          <a:p>
+            <a:endParaRPr lang="ru-UA"/>
+          </a:p>
+        </p:txBody>
+      </p:sp>
+      <p:sp>
+        <p:nvSpPr>
+          <p:cNvPr id="39" name="IMG_MOTIF_2_BACKGROUND">
+            <a:extLst>
+              <a:ext uri="{FF2B5EF4-FFF2-40B4-BE49-F238E27FC236}">
+                <a16:creationId xmlns:a16="http://schemas.microsoft.com/office/drawing/2014/main" id="{1AE5AD94-51B2-3FE1-F876-774397D828D8}"/>
+              </a:ext>
+            </a:extLst>
+          </p:cNvPr>
+          <p:cNvSpPr>
+            <a:spLocks noGrp="1"/>
+          </p:cNvSpPr>
+          <p:nvPr>
+            <p:ph type="pic" sz="quarter" idx="23"/>
+          </p:nvPr>
+        </p:nvSpPr>
+        <p:spPr>
+          <a:xfrm>
+            <a:off x="4748400" y="3542399"/>
+            <a:ext cx="2469600" cy="1389600"/>
+          </a:xfrm>
+        </p:spPr>
+        <p:txBody>
+          <a:bodyPr/>
+          <a:lstStyle/>
+          <a:p>
+            <a:endParaRPr lang="ru-UA"/>
+          </a:p>
+        </p:txBody>
+      </p:sp>
+      <p:sp>
+        <p:nvSpPr>
+          <p:cNvPr id="41" name="IMG_MOTIF_2_MASK">
+            <a:extLst>
+              <a:ext uri="{FF2B5EF4-FFF2-40B4-BE49-F238E27FC236}">
+                <a16:creationId xmlns:a16="http://schemas.microsoft.com/office/drawing/2014/main" id="{E06252D1-117D-D50C-F31A-306885677628}"/>
+              </a:ext>
+            </a:extLst>
+          </p:cNvPr>
+          <p:cNvSpPr>
+            <a:spLocks noGrp="1"/>
+          </p:cNvSpPr>
+          <p:nvPr>
+            <p:ph type="pic" sz="quarter" idx="24"/>
+          </p:nvPr>
+        </p:nvSpPr>
+        <p:spPr>
+          <a:xfrm>
+            <a:off x="8038799" y="3542399"/>
+            <a:ext cx="2469600" cy="1389600"/>
+          </a:xfrm>
+        </p:spPr>
+        <p:txBody>
+          <a:bodyPr/>
+          <a:lstStyle/>
+          <a:p>
+            <a:endParaRPr lang="ru-UA"/>
+          </a:p>
+        </p:txBody>
+      </p:sp>
+      <p:sp>
+        <p:nvSpPr>
+          <p:cNvPr id="43" name="IMG_MOTIF_3_PHOTO">
+            <a:extLst>
+              <a:ext uri="{FF2B5EF4-FFF2-40B4-BE49-F238E27FC236}">
+                <a16:creationId xmlns:a16="http://schemas.microsoft.com/office/drawing/2014/main" id="{1AF4C320-E0F4-8D35-AB7E-39ABA5520542}"/>
+              </a:ext>
+            </a:extLst>
+          </p:cNvPr>
+          <p:cNvSpPr>
+            <a:spLocks noGrp="1"/>
+          </p:cNvSpPr>
+          <p:nvPr>
+            <p:ph type="pic" sz="quarter" idx="25"/>
+          </p:nvPr>
+        </p:nvSpPr>
+        <p:spPr>
+          <a:xfrm>
+            <a:off x="1457999" y="4932000"/>
+            <a:ext cx="2469600" cy="1188000"/>
+          </a:xfrm>
+        </p:spPr>
+        <p:txBody>
+          <a:bodyPr/>
+          <a:lstStyle/>
+          <a:p>
+            <a:endParaRPr lang="ru-UA"/>
+          </a:p>
+        </p:txBody>
+      </p:sp>
+      <p:sp>
+        <p:nvSpPr>
+          <p:cNvPr id="45" name="IMG_MOTIF_3_BACKGROUND">
+            <a:extLst>
+              <a:ext uri="{FF2B5EF4-FFF2-40B4-BE49-F238E27FC236}">
+                <a16:creationId xmlns:a16="http://schemas.microsoft.com/office/drawing/2014/main" id="{E013E4AB-5C01-4C91-69BD-8D27BAEB6C5E}"/>
+              </a:ext>
+            </a:extLst>
+          </p:cNvPr>
+          <p:cNvSpPr>
+            <a:spLocks noGrp="1"/>
+          </p:cNvSpPr>
+          <p:nvPr>
+            <p:ph type="pic" sz="quarter" idx="26"/>
+          </p:nvPr>
+        </p:nvSpPr>
+        <p:spPr>
+          <a:xfrm>
+            <a:off x="4748400" y="4932000"/>
+            <a:ext cx="2469600" cy="1188000"/>
+          </a:xfrm>
+        </p:spPr>
+        <p:txBody>
+          <a:bodyPr/>
+          <a:lstStyle/>
+          <a:p>
+            <a:endParaRPr lang="ru-UA"/>
+          </a:p>
+        </p:txBody>
+      </p:sp>
+      <p:sp>
+        <p:nvSpPr>
+          <p:cNvPr id="47" name="IMG_MOTIF_3_MASK">
+            <a:extLst>
+              <a:ext uri="{FF2B5EF4-FFF2-40B4-BE49-F238E27FC236}">
+                <a16:creationId xmlns:a16="http://schemas.microsoft.com/office/drawing/2014/main" id="{CAE27978-B1B0-FE06-8660-9091E8475261}"/>
+              </a:ext>
+            </a:extLst>
+          </p:cNvPr>
+          <p:cNvSpPr>
+            <a:spLocks noGrp="1"/>
+          </p:cNvSpPr>
+          <p:nvPr>
+            <p:ph type="pic" sz="quarter" idx="27"/>
+          </p:nvPr>
+        </p:nvSpPr>
+        <p:spPr>
+          <a:xfrm>
+            <a:off x="8038799" y="4932000"/>
+            <a:ext cx="2469600" cy="1188000"/>
+          </a:xfrm>
+        </p:spPr>
+        <p:txBody>
+          <a:bodyPr/>
+          <a:lstStyle/>
+          <a:p>
+            <a:endParaRPr lang="ru-UA"/>
+          </a:p>
+        </p:txBody>
+      </p:sp>
+    </p:spTree>
+    <p:extLst>
+      <p:ext uri="{BB962C8B-B14F-4D97-AF65-F5344CB8AC3E}">
+        <p14:creationId xmlns:p14="http://schemas.microsoft.com/office/powerpoint/2010/main" val="934827309"/>
+      </p:ext>
+    </p:extLst>
+  </p:cSld>
+  <p:clrMapOvr>
+    <a:masterClrMapping/>
+  </p:clrMapOvr>
+</p:sldLayout>
+</file>
+
+<file path=ppt/slideLayouts/slideLayout8.xml><?xml version="1.0" encoding="utf-8"?>
+<p:sldLayout xmlns:a="http://schemas.openxmlformats.org/drawingml/2006/main" xmlns:r="http://schemas.openxmlformats.org/officeDocument/2006/relationships" xmlns:p="http://schemas.openxmlformats.org/presentationml/2006/main" preserve="1" userDrawn="1">
+  <p:cSld name="PAGE_07_BESTSELLERS">
+    <p:spTree>
+      <p:nvGrpSpPr>
+        <p:cNvPr id="1" name=""/>
+        <p:cNvGrpSpPr/>
+        <p:nvPr/>
+      </p:nvGrpSpPr>
+      <p:grpSpPr>
+        <a:xfrm>
+          <a:off x="0" y="0"/>
+          <a:ext cx="0" cy="0"/>
+          <a:chOff x="0" y="0"/>
+          <a:chExt cx="0" cy="0"/>
+        </a:xfrm>
+      </p:grpSpPr>
+      <p:sp>
+        <p:nvSpPr>
+          <p:cNvPr id="7" name="Заголовок">
+            <a:extLst>
+              <a:ext uri="{FF2B5EF4-FFF2-40B4-BE49-F238E27FC236}">
+                <a16:creationId xmlns:a16="http://schemas.microsoft.com/office/drawing/2014/main" id="{01F38D04-D37E-E6CE-FF6F-492308578B48}"/>
+              </a:ext>
+            </a:extLst>
+          </p:cNvPr>
+          <p:cNvSpPr txBox="1"/>
+          <p:nvPr userDrawn="1"/>
+        </p:nvSpPr>
+        <p:spPr>
+          <a:xfrm>
+            <a:off x="482400" y="367199"/>
+            <a:ext cx="2505600" cy="991041"/>
+          </a:xfrm>
+          <a:prstGeom prst="rect">
+            <a:avLst/>
+          </a:prstGeom>
+          <a:noFill/>
+        </p:spPr>
+        <p:txBody>
+          <a:bodyPr wrap="square" rtlCol="0">
+            <a:spAutoFit/>
+          </a:bodyPr>
+          <a:lstStyle/>
+          <a:p>
+            <a:r>
+              <a:rPr lang="en-US" sz="2920" b="0" dirty="0">
+                <a:solidFill>
+                  <a:srgbClr val="231F20"/>
+                </a:solidFill>
+                <a:latin typeface="Helvetica Neue" panose="02000806000000020004" pitchFamily="2"/>
+              </a:rPr>
+              <a:t>Best-Seller </a:t>
+            </a:r>
+            <a:r>
+              <a:rPr lang="en-US" sz="2920" b="0" baseline="0" dirty="0">
+                <a:solidFill>
+                  <a:srgbClr val="231F20"/>
+                </a:solidFill>
+                <a:latin typeface="Helvetica Neue" panose="02000806000000020004" pitchFamily="2"/>
+              </a:rPr>
+              <a:t>der</a:t>
+            </a:r>
+            <a:endParaRPr lang="uk-UA" sz="2920" b="0" baseline="0" dirty="0">
+              <a:solidFill>
+                <a:srgbClr val="231F20"/>
+              </a:solidFill>
+            </a:endParaRPr>
+          </a:p>
+          <a:p>
+            <a:r>
+              <a:rPr lang="en-US" sz="2920" b="0" dirty="0">
+                <a:solidFill>
+                  <a:srgbClr val="231F20"/>
+                </a:solidFill>
+                <a:latin typeface="Helvetica Neue" panose="02000806000000020004" pitchFamily="2"/>
+              </a:rPr>
+              <a:t>Saison 2025</a:t>
+            </a:r>
+            <a:endParaRPr lang="ru-UA" sz="2920" b="0" dirty="0">
+              <a:solidFill>
+                <a:srgbClr val="231F20"/>
+              </a:solidFill>
+            </a:endParaRPr>
+          </a:p>
+        </p:txBody>
+      </p:sp>
+      <p:sp>
+        <p:nvSpPr>
+          <p:cNvPr id="8" name="Підзаголовок">
+            <a:extLst>
+              <a:ext uri="{FF2B5EF4-FFF2-40B4-BE49-F238E27FC236}">
+                <a16:creationId xmlns:a16="http://schemas.microsoft.com/office/drawing/2014/main" id="{048AC530-5BE1-CEEA-3695-BB63B95ACEE5}"/>
+              </a:ext>
+            </a:extLst>
+          </p:cNvPr>
+          <p:cNvSpPr txBox="1"/>
+          <p:nvPr userDrawn="1"/>
+        </p:nvSpPr>
+        <p:spPr>
+          <a:xfrm>
+            <a:off x="511200" y="1458000"/>
+            <a:ext cx="3830400" cy="273921"/>
+          </a:xfrm>
+          <a:prstGeom prst="rect">
+            <a:avLst/>
+          </a:prstGeom>
+          <a:noFill/>
+        </p:spPr>
+        <p:txBody>
+          <a:bodyPr wrap="square" rtlCol="0">
+            <a:spAutoFit/>
+          </a:bodyPr>
+          <a:lstStyle/>
+          <a:p>
+            <a:r>
+              <a:rPr lang="en-US" sz="1180" baseline="0" dirty="0">
+                <a:solidFill>
+                  <a:srgbClr val="231F20"/>
+                </a:solidFill>
+                <a:latin typeface="Myriad Pro" panose="020B0503030403020204" pitchFamily="34" charset="0"/>
+              </a:rPr>
+              <a:t>Die </a:t>
+            </a:r>
+            <a:r>
+              <a:rPr lang="en-US" sz="1180" baseline="0" dirty="0" err="1">
+                <a:solidFill>
+                  <a:srgbClr val="231F20"/>
+                </a:solidFill>
+                <a:latin typeface="Myriad Pro" panose="020B0503030403020204" pitchFamily="34" charset="0"/>
+              </a:rPr>
+              <a:t>beliebtesten</a:t>
+            </a:r>
+            <a:r>
+              <a:rPr lang="en-US" sz="1180" baseline="0" dirty="0">
+                <a:solidFill>
+                  <a:srgbClr val="231F20"/>
+                </a:solidFill>
+                <a:latin typeface="Myriad Pro" panose="020B0503030403020204" pitchFamily="34" charset="0"/>
+              </a:rPr>
+              <a:t> Motive...</a:t>
+            </a:r>
+            <a:endParaRPr lang="ru-UA" sz="1180" baseline="0" dirty="0">
+              <a:solidFill>
+                <a:srgbClr val="231F20"/>
+              </a:solidFill>
+              <a:latin typeface="Myriad Pro" panose="020B0503030403020204" pitchFamily="34" charset="0"/>
+            </a:endParaRPr>
+          </a:p>
+        </p:txBody>
+      </p:sp>
+      <p:sp>
+        <p:nvSpPr>
+          <p:cNvPr id="9" name="Підпис 1">
+            <a:extLst>
+              <a:ext uri="{FF2B5EF4-FFF2-40B4-BE49-F238E27FC236}">
+                <a16:creationId xmlns:a16="http://schemas.microsoft.com/office/drawing/2014/main" id="{DDD344C6-DFDD-3D05-29A0-D0EE2A6F68AB}"/>
+              </a:ext>
+            </a:extLst>
+          </p:cNvPr>
+          <p:cNvSpPr txBox="1"/>
+          <p:nvPr userDrawn="1"/>
+        </p:nvSpPr>
+        <p:spPr>
+          <a:xfrm>
+            <a:off x="455400" y="2581845"/>
+            <a:ext cx="1116000" cy="215444"/>
+          </a:xfrm>
+          <a:prstGeom prst="rect">
+            <a:avLst/>
+          </a:prstGeom>
+          <a:noFill/>
+        </p:spPr>
+        <p:txBody>
+          <a:bodyPr wrap="square" rtlCol="0">
+            <a:spAutoFit/>
+          </a:bodyPr>
+          <a:lstStyle/>
+          <a:p>
+            <a:pPr algn="ctr"/>
+            <a:r>
+              <a:rPr lang="en-US" sz="800" dirty="0" err="1"/>
+              <a:t>Weihnachtsrentier</a:t>
+            </a:r>
+            <a:endParaRPr lang="ru-UA" sz="800" dirty="0"/>
+          </a:p>
+        </p:txBody>
+      </p:sp>
+      <p:sp>
+        <p:nvSpPr>
+          <p:cNvPr id="10" name="Підпис 2">
+            <a:extLst>
+              <a:ext uri="{FF2B5EF4-FFF2-40B4-BE49-F238E27FC236}">
+                <a16:creationId xmlns:a16="http://schemas.microsoft.com/office/drawing/2014/main" id="{F5786ED0-672A-4868-3A87-32F00895AAC8}"/>
+              </a:ext>
+            </a:extLst>
+          </p:cNvPr>
+          <p:cNvSpPr txBox="1"/>
+          <p:nvPr userDrawn="1"/>
+        </p:nvSpPr>
+        <p:spPr>
+          <a:xfrm>
+            <a:off x="531000" y="3883426"/>
+            <a:ext cx="968400" cy="338554"/>
+          </a:xfrm>
+          <a:prstGeom prst="rect">
+            <a:avLst/>
+          </a:prstGeom>
+          <a:noFill/>
+        </p:spPr>
+        <p:txBody>
+          <a:bodyPr wrap="square" rtlCol="0">
+            <a:spAutoFit/>
+          </a:bodyPr>
+          <a:lstStyle/>
+          <a:p>
+            <a:pPr algn="ctr"/>
+            <a:r>
+              <a:rPr lang="en-US" sz="800" baseline="0" dirty="0">
+                <a:solidFill>
+                  <a:srgbClr val="231F20"/>
+                </a:solidFill>
+                <a:latin typeface="Myriad Pro" panose="020B0503030403020204" pitchFamily="34" charset="0"/>
+              </a:rPr>
+              <a:t>Santa </a:t>
+            </a:r>
+            <a:r>
+              <a:rPr lang="en-US" sz="800" baseline="0" dirty="0" err="1">
+                <a:solidFill>
+                  <a:srgbClr val="231F20"/>
+                </a:solidFill>
+                <a:latin typeface="Myriad Pro" panose="020B0503030403020204" pitchFamily="34" charset="0"/>
+              </a:rPr>
+              <a:t>mit</a:t>
+            </a:r>
+            <a:r>
+              <a:rPr lang="en-US" sz="800" baseline="0" dirty="0">
+                <a:solidFill>
+                  <a:srgbClr val="231F20"/>
+                </a:solidFill>
+                <a:latin typeface="Myriad Pro" panose="020B0503030403020204" pitchFamily="34" charset="0"/>
+              </a:rPr>
+              <a:t> </a:t>
+            </a:r>
+            <a:r>
+              <a:rPr lang="en-US" sz="800" baseline="0" dirty="0" err="1">
+                <a:solidFill>
+                  <a:srgbClr val="231F20"/>
+                </a:solidFill>
+                <a:latin typeface="Myriad Pro" panose="020B0503030403020204" pitchFamily="34" charset="0"/>
+              </a:rPr>
+              <a:t>Sonnenbrille</a:t>
+            </a:r>
+            <a:endParaRPr lang="ru-UA" sz="800" baseline="0" dirty="0">
+              <a:solidFill>
+                <a:srgbClr val="231F20"/>
+              </a:solidFill>
+              <a:latin typeface="Myriad Pro" panose="020B0503030403020204" pitchFamily="34" charset="0"/>
+            </a:endParaRPr>
+          </a:p>
+        </p:txBody>
+      </p:sp>
+      <p:sp>
+        <p:nvSpPr>
+          <p:cNvPr id="11" name="Підпис 3">
+            <a:extLst>
+              <a:ext uri="{FF2B5EF4-FFF2-40B4-BE49-F238E27FC236}">
+                <a16:creationId xmlns:a16="http://schemas.microsoft.com/office/drawing/2014/main" id="{4F898113-8632-9926-4B23-530966B801A7}"/>
+              </a:ext>
+            </a:extLst>
+          </p:cNvPr>
+          <p:cNvSpPr txBox="1"/>
+          <p:nvPr userDrawn="1"/>
+        </p:nvSpPr>
+        <p:spPr>
+          <a:xfrm>
+            <a:off x="531000" y="5184556"/>
+            <a:ext cx="968400" cy="215444"/>
+          </a:xfrm>
+          <a:prstGeom prst="rect">
+            <a:avLst/>
+          </a:prstGeom>
+          <a:noFill/>
+        </p:spPr>
+        <p:txBody>
+          <a:bodyPr wrap="square" rtlCol="0">
+            <a:spAutoFit/>
+          </a:bodyPr>
+          <a:lstStyle/>
+          <a:p>
+            <a:pPr algn="ctr"/>
+            <a:r>
+              <a:rPr lang="en-US" sz="800" baseline="0" dirty="0">
+                <a:latin typeface="Myriad Pro" panose="020B0503030403020204" pitchFamily="34" charset="0"/>
+              </a:rPr>
+              <a:t>Glühwein-Santa</a:t>
+            </a:r>
+            <a:endParaRPr lang="ru-UA" sz="800" baseline="0" dirty="0">
+              <a:latin typeface="Myriad Pro" panose="020B0503030403020204" pitchFamily="34" charset="0"/>
+            </a:endParaRPr>
+          </a:p>
+        </p:txBody>
+      </p:sp>
+      <p:sp>
+        <p:nvSpPr>
+          <p:cNvPr id="12" name="Fotokarte">
+            <a:extLst>
+              <a:ext uri="{FF2B5EF4-FFF2-40B4-BE49-F238E27FC236}">
+                <a16:creationId xmlns:a16="http://schemas.microsoft.com/office/drawing/2014/main" id="{9DDD4FEC-AF7C-21FE-3C5E-FD3A9F0ACC02}"/>
+              </a:ext>
+            </a:extLst>
+          </p:cNvPr>
+          <p:cNvSpPr txBox="1"/>
+          <p:nvPr userDrawn="1"/>
+        </p:nvSpPr>
+        <p:spPr>
+          <a:xfrm>
+            <a:off x="2934000" y="1828800"/>
+            <a:ext cx="806400" cy="261610"/>
+          </a:xfrm>
+          <a:prstGeom prst="rect">
+            <a:avLst/>
+          </a:prstGeom>
+          <a:noFill/>
+        </p:spPr>
+        <p:txBody>
+          <a:bodyPr wrap="square" rtlCol="0">
+            <a:spAutoFit/>
+          </a:bodyPr>
+          <a:lstStyle/>
+          <a:p>
+            <a:r>
+              <a:rPr lang="en-US" sz="1100" dirty="0" err="1"/>
+              <a:t>Fotokarte</a:t>
+            </a:r>
+            <a:endParaRPr lang="ru-UA" sz="1100" dirty="0"/>
+          </a:p>
+        </p:txBody>
+      </p:sp>
+      <p:sp>
+        <p:nvSpPr>
+          <p:cNvPr id="13" name="Hintergrund">
+            <a:extLst>
+              <a:ext uri="{FF2B5EF4-FFF2-40B4-BE49-F238E27FC236}">
+                <a16:creationId xmlns:a16="http://schemas.microsoft.com/office/drawing/2014/main" id="{41C1236F-8502-35CC-F889-12EC6AD15651}"/>
+              </a:ext>
+            </a:extLst>
+          </p:cNvPr>
+          <p:cNvSpPr txBox="1"/>
+          <p:nvPr userDrawn="1"/>
+        </p:nvSpPr>
+        <p:spPr>
+          <a:xfrm>
+            <a:off x="6098400" y="1814400"/>
+            <a:ext cx="973732" cy="261610"/>
+          </a:xfrm>
+          <a:prstGeom prst="rect">
+            <a:avLst/>
+          </a:prstGeom>
+          <a:noFill/>
+        </p:spPr>
+        <p:txBody>
+          <a:bodyPr wrap="square" rtlCol="0">
+            <a:spAutoFit/>
+          </a:bodyPr>
+          <a:lstStyle/>
+          <a:p>
+            <a:r>
+              <a:rPr lang="en-US" sz="1100" dirty="0" err="1"/>
+              <a:t>Hintergrund</a:t>
+            </a:r>
+            <a:endParaRPr lang="ru-UA" sz="1100" dirty="0"/>
+          </a:p>
+        </p:txBody>
+      </p:sp>
+      <p:sp>
+        <p:nvSpPr>
+          <p:cNvPr id="14" name="TextBox 13">
+            <a:extLst>
+              <a:ext uri="{FF2B5EF4-FFF2-40B4-BE49-F238E27FC236}">
+                <a16:creationId xmlns:a16="http://schemas.microsoft.com/office/drawing/2014/main" id="{CF50393F-47EC-E625-4874-8D39D150FEE4}"/>
+              </a:ext>
+            </a:extLst>
+          </p:cNvPr>
+          <p:cNvSpPr txBox="1"/>
+          <p:nvPr userDrawn="1"/>
+        </p:nvSpPr>
+        <p:spPr>
+          <a:xfrm>
+            <a:off x="9352799" y="1814400"/>
+            <a:ext cx="806399" cy="261610"/>
+          </a:xfrm>
+          <a:prstGeom prst="rect">
+            <a:avLst/>
+          </a:prstGeom>
+          <a:noFill/>
+        </p:spPr>
+        <p:txBody>
+          <a:bodyPr wrap="square" rtlCol="0">
+            <a:spAutoFit/>
+          </a:bodyPr>
+          <a:lstStyle/>
+          <a:p>
+            <a:r>
+              <a:rPr lang="en-US" sz="1100" dirty="0"/>
+              <a:t>AR-Maske</a:t>
+            </a:r>
+            <a:endParaRPr lang="ru-UA" sz="1100" dirty="0"/>
+          </a:p>
+        </p:txBody>
+      </p:sp>
+      <p:sp>
+        <p:nvSpPr>
+          <p:cNvPr id="16" name="Овал 15">
+            <a:extLst>
+              <a:ext uri="{FF2B5EF4-FFF2-40B4-BE49-F238E27FC236}">
+                <a16:creationId xmlns:a16="http://schemas.microsoft.com/office/drawing/2014/main" id="{8086855A-D8D7-BD42-AF2F-8A97FFC29770}"/>
               </a:ext>
             </a:extLst>
           </p:cNvPr>
@@ -3298,7 +4933,7 @@
         </p:nvSpPr>
         <p:spPr>
           <a:xfrm>
-            <a:off x="810000" y="5025600"/>
+            <a:off x="813600" y="2142000"/>
             <a:ext cx="399600" cy="399600"/>
           </a:xfrm>
           <a:prstGeom prst="ellipse">
@@ -3340,10 +4975,55 @@
       </p:sp>
       <p:sp>
         <p:nvSpPr>
-          <p:cNvPr id="9" name="Прямокутник 8">
-            <a:extLst>
-              <a:ext uri="{FF2B5EF4-FFF2-40B4-BE49-F238E27FC236}">
-                <a16:creationId xmlns:a16="http://schemas.microsoft.com/office/drawing/2014/main" id="{DC43FDCC-3711-7C9A-89D0-597FAB6EBD05}"/>
+          <p:cNvPr id="18" name="TextBox 17">
+            <a:extLst>
+              <a:ext uri="{FF2B5EF4-FFF2-40B4-BE49-F238E27FC236}">
+                <a16:creationId xmlns:a16="http://schemas.microsoft.com/office/drawing/2014/main" id="{35A92245-DA62-C83E-E23C-D1794C66E3C4}"/>
+              </a:ext>
+            </a:extLst>
+          </p:cNvPr>
+          <p:cNvSpPr txBox="1"/>
+          <p:nvPr userDrawn="1"/>
+        </p:nvSpPr>
+        <p:spPr>
+          <a:xfrm>
+            <a:off x="846000" y="2142000"/>
+            <a:ext cx="169200" cy="345600"/>
+          </a:xfrm>
+          <a:prstGeom prst="rect">
+            <a:avLst/>
+          </a:prstGeom>
+          <a:noFill/>
+        </p:spPr>
+        <p:txBody>
+          <a:bodyPr wrap="square">
+            <a:spAutoFit/>
+          </a:bodyPr>
+          <a:lstStyle/>
+          <a:p>
+            <a:r>
+              <a:rPr lang="en-US" sz="2240" baseline="0" dirty="0">
+                <a:solidFill>
+                  <a:srgbClr val="C5923B"/>
+                </a:solidFill>
+                <a:latin typeface="Core Serif N 75 Black" panose="02020504080301010804" pitchFamily="18"/>
+              </a:rPr>
+              <a:t>1</a:t>
+            </a:r>
+            <a:endParaRPr lang="ru-UA" sz="2240" baseline="0" dirty="0">
+              <a:solidFill>
+                <a:srgbClr val="C5923B"/>
+              </a:solidFill>
+            </a:endParaRPr>
+          </a:p>
+        </p:txBody>
+      </p:sp>
+      <p:sp>
+        <p:nvSpPr>
+          <p:cNvPr id="23" name="Овал 22">
+            <a:extLst>
+              <a:ext uri="{FF2B5EF4-FFF2-40B4-BE49-F238E27FC236}">
+                <a16:creationId xmlns:a16="http://schemas.microsoft.com/office/drawing/2014/main" id="{68661AB3-F555-E431-2F28-02576FA8132C}"/>
               </a:ext>
             </a:extLst>
           </p:cNvPr>
@@ -3352,16 +5032,16 @@
         </p:nvSpPr>
         <p:spPr>
           <a:xfrm>
-            <a:off x="1126800" y="6170400"/>
-            <a:ext cx="6296400" cy="500400"/>
-          </a:xfrm>
-          <a:prstGeom prst="rect">
+            <a:off x="813600" y="3437679"/>
+            <a:ext cx="399600" cy="399600"/>
+          </a:xfrm>
+          <a:prstGeom prst="ellipse">
             <a:avLst/>
           </a:prstGeom>
           <a:solidFill>
-            <a:srgbClr val="001518"/>
+            <a:srgbClr val="001319"/>
           </a:solidFill>
-          <a:ln>
+          <a:ln w="19050">
             <a:solidFill>
               <a:srgbClr val="C5923B"/>
             </a:solidFill>
@@ -3394,371 +5074,10 @@
       </p:sp>
       <p:sp>
         <p:nvSpPr>
-          <p:cNvPr id="11" name="TXT_MOTIF_HEADLINE">
-            <a:extLst>
-              <a:ext uri="{FF2B5EF4-FFF2-40B4-BE49-F238E27FC236}">
-                <a16:creationId xmlns:a16="http://schemas.microsoft.com/office/drawing/2014/main" id="{36C30D00-93A3-4E22-8A60-31A066430BCE}"/>
-              </a:ext>
-            </a:extLst>
-          </p:cNvPr>
-          <p:cNvSpPr>
-            <a:spLocks noGrp="1"/>
-          </p:cNvSpPr>
-          <p:nvPr>
-            <p:ph type="body" sz="quarter" idx="10"/>
-          </p:nvPr>
-        </p:nvSpPr>
-        <p:spPr>
-          <a:xfrm>
-            <a:off x="482400" y="367200"/>
-            <a:ext cx="4658400" cy="687600"/>
-          </a:xfrm>
-        </p:spPr>
-        <p:txBody>
-          <a:bodyPr/>
-          <a:lstStyle>
-            <a:lvl1pPr>
-              <a:buNone/>
-              <a:defRPr sz="2480" baseline="0">
-                <a:solidFill>
-                  <a:srgbClr val="231F20"/>
-                </a:solidFill>
-              </a:defRPr>
-            </a:lvl1pPr>
-            <a:lvl2pPr>
-              <a:buNone/>
-              <a:defRPr sz="2480" baseline="0">
-                <a:solidFill>
-                  <a:srgbClr val="231F20"/>
-                </a:solidFill>
-              </a:defRPr>
-            </a:lvl2pPr>
-            <a:lvl3pPr>
-              <a:buNone/>
-              <a:defRPr sz="2480" baseline="0">
-                <a:solidFill>
-                  <a:srgbClr val="231F20"/>
-                </a:solidFill>
-              </a:defRPr>
-            </a:lvl3pPr>
-            <a:lvl4pPr>
-              <a:buNone/>
-              <a:defRPr sz="2480" baseline="0">
-                <a:solidFill>
-                  <a:srgbClr val="231F20"/>
-                </a:solidFill>
-              </a:defRPr>
-            </a:lvl4pPr>
-            <a:lvl5pPr>
-              <a:buNone/>
-              <a:defRPr sz="2480" baseline="0">
-                <a:solidFill>
-                  <a:srgbClr val="231F20"/>
-                </a:solidFill>
-              </a:defRPr>
-            </a:lvl5pPr>
-          </a:lstStyle>
-          <a:p>
-            <a:pPr lvl="0"/>
-            <a:r>
-              <a:rPr lang="uk-UA" dirty="0"/>
-              <a:t>Клацніть, щоб відредагувати стилі зразків тексту</a:t>
-            </a:r>
-          </a:p>
-        </p:txBody>
-      </p:sp>
-      <p:sp>
-        <p:nvSpPr>
-          <p:cNvPr id="13" name="TXT_MOTIF_SUBHEADLINE">
-            <a:extLst>
-              <a:ext uri="{FF2B5EF4-FFF2-40B4-BE49-F238E27FC236}">
-                <a16:creationId xmlns:a16="http://schemas.microsoft.com/office/drawing/2014/main" id="{FC617ACC-84D0-4AF4-0FC6-7A6936FC25C5}"/>
-              </a:ext>
-            </a:extLst>
-          </p:cNvPr>
-          <p:cNvSpPr>
-            <a:spLocks noGrp="1"/>
-          </p:cNvSpPr>
-          <p:nvPr>
-            <p:ph type="body" sz="quarter" idx="11"/>
-          </p:nvPr>
-        </p:nvSpPr>
-        <p:spPr>
-          <a:xfrm>
-            <a:off x="511200" y="1335600"/>
-            <a:ext cx="3715200" cy="345600"/>
-          </a:xfrm>
-        </p:spPr>
-        <p:txBody>
-          <a:bodyPr/>
-          <a:lstStyle>
-            <a:lvl1pPr>
-              <a:buNone/>
-              <a:defRPr sz="1113" baseline="0">
-                <a:solidFill>
-                  <a:srgbClr val="231F20"/>
-                </a:solidFill>
-                <a:latin typeface="Myriad Pro" panose="020B0503030403020204" pitchFamily="34" charset="0"/>
-              </a:defRPr>
-            </a:lvl1pPr>
-            <a:lvl2pPr>
-              <a:buNone/>
-              <a:defRPr sz="1113" baseline="0">
-                <a:solidFill>
-                  <a:srgbClr val="231F20"/>
-                </a:solidFill>
-                <a:latin typeface="Myriad Pro" panose="020B0503030403020204" pitchFamily="34" charset="0"/>
-              </a:defRPr>
-            </a:lvl2pPr>
-            <a:lvl3pPr>
-              <a:buNone/>
-              <a:defRPr sz="1113" baseline="0">
-                <a:solidFill>
-                  <a:srgbClr val="231F20"/>
-                </a:solidFill>
-                <a:latin typeface="Myriad Pro" panose="020B0503030403020204" pitchFamily="34" charset="0"/>
-              </a:defRPr>
-            </a:lvl3pPr>
-            <a:lvl4pPr>
-              <a:buNone/>
-              <a:defRPr sz="1113" baseline="0">
-                <a:solidFill>
-                  <a:srgbClr val="231F20"/>
-                </a:solidFill>
-                <a:latin typeface="Myriad Pro" panose="020B0503030403020204" pitchFamily="34" charset="0"/>
-              </a:defRPr>
-            </a:lvl4pPr>
-            <a:lvl5pPr>
-              <a:buNone/>
-              <a:defRPr sz="1113" baseline="0">
-                <a:solidFill>
-                  <a:srgbClr val="231F20"/>
-                </a:solidFill>
-                <a:latin typeface="Myriad Pro" panose="020B0503030403020204" pitchFamily="34" charset="0"/>
-              </a:defRPr>
-            </a:lvl5pPr>
-          </a:lstStyle>
-          <a:p>
-            <a:pPr lvl="0"/>
-            <a:r>
-              <a:rPr lang="uk-UA" dirty="0"/>
-              <a:t>Клацніть, щоб відредагувати стилі зразків тексту</a:t>
-            </a:r>
-            <a:endParaRPr lang="ru-UA" dirty="0"/>
-          </a:p>
-        </p:txBody>
-      </p:sp>
-      <p:sp>
-        <p:nvSpPr>
-          <p:cNvPr id="15" name="TXT_THEME_WORLD_NAME">
-            <a:extLst>
-              <a:ext uri="{FF2B5EF4-FFF2-40B4-BE49-F238E27FC236}">
-                <a16:creationId xmlns:a16="http://schemas.microsoft.com/office/drawing/2014/main" id="{5D94B055-A168-5625-12D4-2D458A552309}"/>
-              </a:ext>
-            </a:extLst>
-          </p:cNvPr>
-          <p:cNvSpPr>
-            <a:spLocks noGrp="1"/>
-          </p:cNvSpPr>
-          <p:nvPr>
-            <p:ph type="body" sz="quarter" idx="12"/>
-          </p:nvPr>
-        </p:nvSpPr>
-        <p:spPr>
-          <a:xfrm>
-            <a:off x="511199" y="1742400"/>
-            <a:ext cx="5400000" cy="194400"/>
-          </a:xfrm>
-        </p:spPr>
-        <p:txBody>
-          <a:bodyPr/>
-          <a:lstStyle>
-            <a:lvl1pPr>
-              <a:buNone/>
-              <a:defRPr sz="1430" baseline="0">
-                <a:solidFill>
-                  <a:srgbClr val="231F20"/>
-                </a:solidFill>
-              </a:defRPr>
-            </a:lvl1pPr>
-            <a:lvl2pPr>
-              <a:buNone/>
-              <a:defRPr sz="1430" baseline="0">
-                <a:solidFill>
-                  <a:srgbClr val="231F20"/>
-                </a:solidFill>
-              </a:defRPr>
-            </a:lvl2pPr>
-            <a:lvl3pPr>
-              <a:buNone/>
-              <a:defRPr sz="1430" baseline="0">
-                <a:solidFill>
-                  <a:srgbClr val="231F20"/>
-                </a:solidFill>
-              </a:defRPr>
-            </a:lvl3pPr>
-            <a:lvl4pPr>
-              <a:buNone/>
-              <a:defRPr sz="1430" baseline="0">
-                <a:solidFill>
-                  <a:srgbClr val="231F20"/>
-                </a:solidFill>
-              </a:defRPr>
-            </a:lvl4pPr>
-            <a:lvl5pPr>
-              <a:buNone/>
-              <a:defRPr sz="1430" baseline="0">
-                <a:solidFill>
-                  <a:srgbClr val="231F20"/>
-                </a:solidFill>
-              </a:defRPr>
-            </a:lvl5pPr>
-          </a:lstStyle>
-          <a:p>
-            <a:pPr lvl="0"/>
-            <a:r>
-              <a:rPr lang="uk-UA" dirty="0"/>
-              <a:t>Клацніть, щоб відредагувати стилі зразків тексту</a:t>
-            </a:r>
-          </a:p>
-        </p:txBody>
-      </p:sp>
-      <p:sp>
-        <p:nvSpPr>
-          <p:cNvPr id="17" name="TXT_MOTIF_COLUMN_HEADER_1">
-            <a:extLst>
-              <a:ext uri="{FF2B5EF4-FFF2-40B4-BE49-F238E27FC236}">
-                <a16:creationId xmlns:a16="http://schemas.microsoft.com/office/drawing/2014/main" id="{F10BC6DA-36B3-B4E5-680F-6924CD22C7E4}"/>
-              </a:ext>
-            </a:extLst>
-          </p:cNvPr>
-          <p:cNvSpPr>
-            <a:spLocks noGrp="1"/>
-          </p:cNvSpPr>
-          <p:nvPr>
-            <p:ph type="body" sz="quarter" idx="13" hasCustomPrompt="1"/>
-          </p:nvPr>
-        </p:nvSpPr>
-        <p:spPr>
-          <a:xfrm>
-            <a:off x="3052800" y="2059200"/>
-            <a:ext cx="597600" cy="187200"/>
-          </a:xfrm>
-        </p:spPr>
-        <p:txBody>
-          <a:bodyPr/>
-          <a:lstStyle>
-            <a:lvl1pPr>
-              <a:buNone/>
-              <a:defRPr sz="1170" baseline="0">
-                <a:solidFill>
-                  <a:srgbClr val="231F20"/>
-                </a:solidFill>
-                <a:latin typeface="Myriad Pro" panose="020B0503030403020204" pitchFamily="34" charset="0"/>
-              </a:defRPr>
-            </a:lvl1pPr>
-          </a:lstStyle>
-          <a:p>
-            <a:pPr lvl="0"/>
-            <a:r>
-              <a:rPr lang="en-US" dirty="0"/>
-              <a:t>ff</a:t>
-            </a:r>
-            <a:endParaRPr lang="ru-UA" dirty="0"/>
-          </a:p>
-        </p:txBody>
-      </p:sp>
-      <p:sp>
-        <p:nvSpPr>
-          <p:cNvPr id="19" name="TXT_MOTIF_COLUMN_HEADER_23">
-            <a:extLst>
-              <a:ext uri="{FF2B5EF4-FFF2-40B4-BE49-F238E27FC236}">
-                <a16:creationId xmlns:a16="http://schemas.microsoft.com/office/drawing/2014/main" id="{4B4B0961-A4F9-7785-EEB8-D9FEDA9D9282}"/>
-              </a:ext>
-            </a:extLst>
-          </p:cNvPr>
-          <p:cNvSpPr>
-            <a:spLocks noGrp="1"/>
-          </p:cNvSpPr>
-          <p:nvPr>
-            <p:ph type="body" sz="quarter" idx="14"/>
-          </p:nvPr>
-        </p:nvSpPr>
-        <p:spPr>
-          <a:xfrm>
-            <a:off x="5864399" y="2041200"/>
-            <a:ext cx="2916000" cy="187200"/>
-          </a:xfrm>
-        </p:spPr>
-        <p:txBody>
-          <a:bodyPr/>
-          <a:lstStyle>
-            <a:lvl1pPr>
-              <a:buNone/>
-              <a:defRPr sz="1180" baseline="0">
-                <a:solidFill>
-                  <a:srgbClr val="231F20"/>
-                </a:solidFill>
-                <a:latin typeface="Myriad Pro" panose="020B0503030403020204" pitchFamily="34" charset="0"/>
-              </a:defRPr>
-            </a:lvl1pPr>
-            <a:lvl2pPr>
-              <a:buNone/>
-              <a:defRPr sz="1180" baseline="0">
-                <a:solidFill>
-                  <a:srgbClr val="231F20"/>
-                </a:solidFill>
-                <a:latin typeface="Myriad Pro" panose="020B0503030403020204" pitchFamily="34" charset="0"/>
-              </a:defRPr>
-            </a:lvl2pPr>
-            <a:lvl3pPr>
-              <a:buNone/>
-              <a:defRPr sz="1180" baseline="0">
-                <a:solidFill>
-                  <a:srgbClr val="231F20"/>
-                </a:solidFill>
-                <a:latin typeface="Myriad Pro" panose="020B0503030403020204" pitchFamily="34" charset="0"/>
-              </a:defRPr>
-            </a:lvl3pPr>
-            <a:lvl4pPr>
-              <a:buNone/>
-              <a:defRPr sz="1180" baseline="0">
-                <a:solidFill>
-                  <a:srgbClr val="231F20"/>
-                </a:solidFill>
-                <a:latin typeface="Myriad Pro" panose="020B0503030403020204" pitchFamily="34" charset="0"/>
-              </a:defRPr>
-            </a:lvl4pPr>
-            <a:lvl5pPr>
-              <a:buNone/>
-              <a:defRPr sz="1180" baseline="0">
-                <a:solidFill>
-                  <a:srgbClr val="231F20"/>
-                </a:solidFill>
-                <a:latin typeface="Myriad Pro" panose="020B0503030403020204" pitchFamily="34" charset="0"/>
-              </a:defRPr>
-            </a:lvl5pPr>
-          </a:lstStyle>
-          <a:p>
-            <a:pPr lvl="0"/>
-            <a:r>
-              <a:rPr lang="uk-UA" dirty="0"/>
-              <a:t>Клацніть</a:t>
-            </a:r>
-            <a:endParaRPr lang="en-US" dirty="0"/>
-          </a:p>
-          <a:p>
-            <a:pPr lvl="0"/>
-            <a:endParaRPr lang="ru-UA" dirty="0"/>
-          </a:p>
-        </p:txBody>
-      </p:sp>
-      <p:sp>
-        <p:nvSpPr>
-          <p:cNvPr id="21" name="TXT_MOTIF_ROW_NUMBER_1">
-            <a:extLst>
-              <a:ext uri="{FF2B5EF4-FFF2-40B4-BE49-F238E27FC236}">
-                <a16:creationId xmlns:a16="http://schemas.microsoft.com/office/drawing/2014/main" id="{A1AAAA45-CD44-4FEE-BF56-C8ECDA18D445}"/>
+          <p:cNvPr id="24" name="TextBox 23">
+            <a:extLst>
+              <a:ext uri="{FF2B5EF4-FFF2-40B4-BE49-F238E27FC236}">
+                <a16:creationId xmlns:a16="http://schemas.microsoft.com/office/drawing/2014/main" id="{71BC77BE-6215-0A15-C60D-95D84404C49C}"/>
               </a:ext>
             </a:extLst>
           </p:cNvPr>
@@ -3767,8 +5086,8 @@
         </p:nvSpPr>
         <p:spPr>
           <a:xfrm>
-            <a:off x="925200" y="2455200"/>
-            <a:ext cx="176400" cy="437043"/>
+            <a:off x="846000" y="3437679"/>
+            <a:ext cx="169200" cy="437043"/>
           </a:xfrm>
           <a:prstGeom prst="rect">
             <a:avLst/>
@@ -3776,7 +5095,7 @@
           <a:noFill/>
         </p:spPr>
         <p:txBody>
-          <a:bodyPr wrap="square" rtlCol="0">
+          <a:bodyPr wrap="square">
             <a:spAutoFit/>
           </a:bodyPr>
           <a:lstStyle/>
@@ -3788,7 +5107,7 @@
                 </a:solidFill>
                 <a:latin typeface="Core Serif N 75 Black" panose="02020504080301010804" pitchFamily="18"/>
               </a:rPr>
-              <a:t>1</a:t>
+              <a:t>2</a:t>
             </a:r>
             <a:endParaRPr lang="ru-UA" sz="2240" baseline="0" dirty="0">
               <a:solidFill>
@@ -3800,10 +5119,64 @@
       </p:sp>
       <p:sp>
         <p:nvSpPr>
-          <p:cNvPr id="22" name="TXT_MOTIF_ROW_NUMBER_2">
-            <a:extLst>
-              <a:ext uri="{FF2B5EF4-FFF2-40B4-BE49-F238E27FC236}">
-                <a16:creationId xmlns:a16="http://schemas.microsoft.com/office/drawing/2014/main" id="{CB1E552E-C499-44F7-6EF2-74CE56EFBF32}"/>
+          <p:cNvPr id="25" name="Овал 24">
+            <a:extLst>
+              <a:ext uri="{FF2B5EF4-FFF2-40B4-BE49-F238E27FC236}">
+                <a16:creationId xmlns:a16="http://schemas.microsoft.com/office/drawing/2014/main" id="{BD5E062B-2C7C-8F41-95D0-443CE9510F32}"/>
+              </a:ext>
+            </a:extLst>
+          </p:cNvPr>
+          <p:cNvSpPr/>
+          <p:nvPr userDrawn="1"/>
+        </p:nvSpPr>
+        <p:spPr>
+          <a:xfrm>
+            <a:off x="813600" y="4733358"/>
+            <a:ext cx="399600" cy="399600"/>
+          </a:xfrm>
+          <a:prstGeom prst="ellipse">
+            <a:avLst/>
+          </a:prstGeom>
+          <a:solidFill>
+            <a:srgbClr val="001319"/>
+          </a:solidFill>
+          <a:ln w="19050">
+            <a:solidFill>
+              <a:srgbClr val="C5923B"/>
+            </a:solidFill>
+          </a:ln>
+        </p:spPr>
+        <p:style>
+          <a:lnRef idx="2">
+            <a:schemeClr val="accent1">
+              <a:shade val="15000"/>
+            </a:schemeClr>
+          </a:lnRef>
+          <a:fillRef idx="1">
+            <a:schemeClr val="accent1"/>
+          </a:fillRef>
+          <a:effectRef idx="0">
+            <a:schemeClr val="accent1"/>
+          </a:effectRef>
+          <a:fontRef idx="minor">
+            <a:schemeClr val="lt1"/>
+          </a:fontRef>
+        </p:style>
+        <p:txBody>
+          <a:bodyPr rtlCol="0" anchor="ctr"/>
+          <a:lstStyle/>
+          <a:p>
+            <a:pPr algn="ctr"/>
+            <a:endParaRPr lang="ru-UA"/>
+          </a:p>
+        </p:txBody>
+      </p:sp>
+      <p:sp>
+        <p:nvSpPr>
+          <p:cNvPr id="26" name="TextBox 25">
+            <a:extLst>
+              <a:ext uri="{FF2B5EF4-FFF2-40B4-BE49-F238E27FC236}">
+                <a16:creationId xmlns:a16="http://schemas.microsoft.com/office/drawing/2014/main" id="{EA77EE88-CFCC-1732-A7CF-5D87C5EDE389}"/>
               </a:ext>
             </a:extLst>
           </p:cNvPr>
@@ -3812,8 +5185,8 @@
         </p:nvSpPr>
         <p:spPr>
           <a:xfrm>
-            <a:off x="925200" y="3798000"/>
-            <a:ext cx="176400" cy="437043"/>
+            <a:off x="846000" y="4733358"/>
+            <a:ext cx="169200" cy="437043"/>
           </a:xfrm>
           <a:prstGeom prst="rect">
             <a:avLst/>
@@ -3821,19 +5194,19 @@
           <a:noFill/>
         </p:spPr>
         <p:txBody>
-          <a:bodyPr wrap="square" rtlCol="0">
+          <a:bodyPr wrap="square">
             <a:spAutoFit/>
           </a:bodyPr>
           <a:lstStyle/>
           <a:p>
             <a:r>
-              <a:rPr lang="uk-UA" sz="2240" baseline="0" dirty="0">
+              <a:rPr lang="en-US" sz="2240" baseline="0" dirty="0">
                 <a:solidFill>
                   <a:srgbClr val="C5923B"/>
                 </a:solidFill>
                 <a:latin typeface="Core Serif N 75 Black" panose="02020504080301010804" pitchFamily="18"/>
               </a:rPr>
-              <a:t>2</a:t>
+              <a:t>3</a:t>
             </a:r>
             <a:endParaRPr lang="ru-UA" sz="2240" baseline="0" dirty="0">
               <a:solidFill>
@@ -3843,655 +5216,10 @@
           </a:p>
         </p:txBody>
       </p:sp>
-      <p:sp>
-        <p:nvSpPr>
-          <p:cNvPr id="23" name="TXT_MOTIF_ROW_NUMBER_3">
-            <a:extLst>
-              <a:ext uri="{FF2B5EF4-FFF2-40B4-BE49-F238E27FC236}">
-                <a16:creationId xmlns:a16="http://schemas.microsoft.com/office/drawing/2014/main" id="{93D3648D-95D3-798E-B955-D3E2F2774187}"/>
-              </a:ext>
-            </a:extLst>
-          </p:cNvPr>
-          <p:cNvSpPr txBox="1"/>
-          <p:nvPr userDrawn="1"/>
-        </p:nvSpPr>
-        <p:spPr>
-          <a:xfrm>
-            <a:off x="925200" y="5047200"/>
-            <a:ext cx="176400" cy="437043"/>
-          </a:xfrm>
-          <a:prstGeom prst="rect">
-            <a:avLst/>
-          </a:prstGeom>
-          <a:noFill/>
-        </p:spPr>
-        <p:txBody>
-          <a:bodyPr wrap="square" rtlCol="0">
-            <a:spAutoFit/>
-          </a:bodyPr>
-          <a:lstStyle/>
-          <a:p>
-            <a:r>
-              <a:rPr lang="uk-UA" sz="2240" baseline="0" dirty="0">
-                <a:solidFill>
-                  <a:srgbClr val="C5923B"/>
-                </a:solidFill>
-                <a:latin typeface="Core Serif N 75 Black" panose="02020504080301010804" pitchFamily="18"/>
-              </a:rPr>
-              <a:t>3</a:t>
-            </a:r>
-            <a:endParaRPr lang="ru-UA" sz="2240" baseline="0" dirty="0">
-              <a:solidFill>
-                <a:srgbClr val="C5923B"/>
-              </a:solidFill>
-            </a:endParaRPr>
-          </a:p>
-        </p:txBody>
-      </p:sp>
-      <p:sp>
-        <p:nvSpPr>
-          <p:cNvPr id="25" name="TXT_MOTIF_3_NAME">
-            <a:extLst>
-              <a:ext uri="{FF2B5EF4-FFF2-40B4-BE49-F238E27FC236}">
-                <a16:creationId xmlns:a16="http://schemas.microsoft.com/office/drawing/2014/main" id="{C962E585-BC6A-437F-56ED-9EBF60285529}"/>
-              </a:ext>
-            </a:extLst>
-          </p:cNvPr>
-          <p:cNvSpPr>
-            <a:spLocks noGrp="1"/>
-          </p:cNvSpPr>
-          <p:nvPr>
-            <p:ph type="body" sz="quarter" idx="15"/>
-          </p:nvPr>
-        </p:nvSpPr>
-        <p:spPr>
-          <a:xfrm>
-            <a:off x="568800" y="2948400"/>
-            <a:ext cx="1044000" cy="255600"/>
-          </a:xfrm>
-        </p:spPr>
-        <p:txBody>
-          <a:bodyPr/>
-          <a:lstStyle>
-            <a:lvl1pPr>
-              <a:buNone/>
-              <a:defRPr sz="830" baseline="0">
-                <a:solidFill>
-                  <a:srgbClr val="231F20"/>
-                </a:solidFill>
-                <a:latin typeface="Myriad Pro" panose="020B0503030403020204" pitchFamily="34" charset="0"/>
-              </a:defRPr>
-            </a:lvl1pPr>
-            <a:lvl2pPr>
-              <a:buNone/>
-              <a:defRPr sz="830" baseline="0">
-                <a:solidFill>
-                  <a:srgbClr val="231F20"/>
-                </a:solidFill>
-                <a:latin typeface="Myriad Pro" panose="020B0503030403020204" pitchFamily="34" charset="0"/>
-              </a:defRPr>
-            </a:lvl2pPr>
-            <a:lvl3pPr>
-              <a:buNone/>
-              <a:defRPr sz="830" baseline="0">
-                <a:solidFill>
-                  <a:srgbClr val="231F20"/>
-                </a:solidFill>
-                <a:latin typeface="Myriad Pro" panose="020B0503030403020204" pitchFamily="34" charset="0"/>
-              </a:defRPr>
-            </a:lvl3pPr>
-            <a:lvl4pPr>
-              <a:buNone/>
-              <a:defRPr sz="830" baseline="0">
-                <a:solidFill>
-                  <a:srgbClr val="231F20"/>
-                </a:solidFill>
-                <a:latin typeface="Myriad Pro" panose="020B0503030403020204" pitchFamily="34" charset="0"/>
-              </a:defRPr>
-            </a:lvl4pPr>
-            <a:lvl5pPr>
-              <a:buNone/>
-              <a:defRPr sz="830" baseline="0">
-                <a:solidFill>
-                  <a:srgbClr val="231F20"/>
-                </a:solidFill>
-                <a:latin typeface="Myriad Pro" panose="020B0503030403020204" pitchFamily="34" charset="0"/>
-              </a:defRPr>
-            </a:lvl5pPr>
-          </a:lstStyle>
-          <a:p>
-            <a:pPr lvl="0"/>
-            <a:r>
-              <a:rPr lang="uk-UA" dirty="0"/>
-              <a:t>Клацніть,</a:t>
-            </a:r>
-            <a:endParaRPr lang="en-US" dirty="0"/>
-          </a:p>
-          <a:p>
-            <a:pPr lvl="0"/>
-            <a:endParaRPr lang="uk-UA" dirty="0"/>
-          </a:p>
-        </p:txBody>
-      </p:sp>
-      <p:sp>
-        <p:nvSpPr>
-          <p:cNvPr id="26" name="TXT_MOTIF_2_NAME">
-            <a:extLst>
-              <a:ext uri="{FF2B5EF4-FFF2-40B4-BE49-F238E27FC236}">
-                <a16:creationId xmlns:a16="http://schemas.microsoft.com/office/drawing/2014/main" id="{8D7654FD-3710-64A6-21C5-42749B6A42D9}"/>
-              </a:ext>
-            </a:extLst>
-          </p:cNvPr>
-          <p:cNvSpPr>
-            <a:spLocks noGrp="1"/>
-          </p:cNvSpPr>
-          <p:nvPr>
-            <p:ph type="body" sz="quarter" idx="16"/>
-          </p:nvPr>
-        </p:nvSpPr>
-        <p:spPr>
-          <a:xfrm>
-            <a:off x="568800" y="4266000"/>
-            <a:ext cx="1044000" cy="255600"/>
-          </a:xfrm>
-        </p:spPr>
-        <p:txBody>
-          <a:bodyPr/>
-          <a:lstStyle>
-            <a:lvl1pPr>
-              <a:buNone/>
-              <a:defRPr sz="830" baseline="0">
-                <a:solidFill>
-                  <a:srgbClr val="231F20"/>
-                </a:solidFill>
-                <a:latin typeface="Myriad Pro" panose="020B0503030403020204" pitchFamily="34" charset="0"/>
-              </a:defRPr>
-            </a:lvl1pPr>
-            <a:lvl2pPr>
-              <a:buNone/>
-              <a:defRPr sz="830" baseline="0">
-                <a:solidFill>
-                  <a:srgbClr val="231F20"/>
-                </a:solidFill>
-                <a:latin typeface="Myriad Pro" panose="020B0503030403020204" pitchFamily="34" charset="0"/>
-              </a:defRPr>
-            </a:lvl2pPr>
-            <a:lvl3pPr>
-              <a:buNone/>
-              <a:defRPr sz="830" baseline="0">
-                <a:solidFill>
-                  <a:srgbClr val="231F20"/>
-                </a:solidFill>
-                <a:latin typeface="Myriad Pro" panose="020B0503030403020204" pitchFamily="34" charset="0"/>
-              </a:defRPr>
-            </a:lvl3pPr>
-            <a:lvl4pPr>
-              <a:buNone/>
-              <a:defRPr sz="830" baseline="0">
-                <a:solidFill>
-                  <a:srgbClr val="231F20"/>
-                </a:solidFill>
-                <a:latin typeface="Myriad Pro" panose="020B0503030403020204" pitchFamily="34" charset="0"/>
-              </a:defRPr>
-            </a:lvl4pPr>
-            <a:lvl5pPr>
-              <a:buNone/>
-              <a:defRPr sz="830" baseline="0">
-                <a:solidFill>
-                  <a:srgbClr val="231F20"/>
-                </a:solidFill>
-                <a:latin typeface="Myriad Pro" panose="020B0503030403020204" pitchFamily="34" charset="0"/>
-              </a:defRPr>
-            </a:lvl5pPr>
-          </a:lstStyle>
-          <a:p>
-            <a:pPr lvl="0"/>
-            <a:r>
-              <a:rPr lang="uk-UA" dirty="0"/>
-              <a:t>Клацніть,</a:t>
-            </a:r>
-            <a:endParaRPr lang="en-US" dirty="0"/>
-          </a:p>
-          <a:p>
-            <a:pPr lvl="0"/>
-            <a:endParaRPr lang="uk-UA" dirty="0"/>
-          </a:p>
-        </p:txBody>
-      </p:sp>
-      <p:sp>
-        <p:nvSpPr>
-          <p:cNvPr id="27" name="TXT_MOTIF_1_NAME">
-            <a:extLst>
-              <a:ext uri="{FF2B5EF4-FFF2-40B4-BE49-F238E27FC236}">
-                <a16:creationId xmlns:a16="http://schemas.microsoft.com/office/drawing/2014/main" id="{7241013F-BB8B-DAFA-7457-EB1A73F821A9}"/>
-              </a:ext>
-            </a:extLst>
-          </p:cNvPr>
-          <p:cNvSpPr>
-            <a:spLocks noGrp="1"/>
-          </p:cNvSpPr>
-          <p:nvPr>
-            <p:ph type="body" sz="quarter" idx="17"/>
-          </p:nvPr>
-        </p:nvSpPr>
-        <p:spPr>
-          <a:xfrm>
-            <a:off x="568800" y="5522400"/>
-            <a:ext cx="1044000" cy="255600"/>
-          </a:xfrm>
-        </p:spPr>
-        <p:txBody>
-          <a:bodyPr/>
-          <a:lstStyle>
-            <a:lvl1pPr>
-              <a:buNone/>
-              <a:defRPr sz="830" baseline="0">
-                <a:solidFill>
-                  <a:srgbClr val="231F20"/>
-                </a:solidFill>
-                <a:latin typeface="Myriad Pro" panose="020B0503030403020204" pitchFamily="34" charset="0"/>
-              </a:defRPr>
-            </a:lvl1pPr>
-            <a:lvl2pPr>
-              <a:buNone/>
-              <a:defRPr sz="830" baseline="0">
-                <a:solidFill>
-                  <a:srgbClr val="231F20"/>
-                </a:solidFill>
-                <a:latin typeface="Myriad Pro" panose="020B0503030403020204" pitchFamily="34" charset="0"/>
-              </a:defRPr>
-            </a:lvl2pPr>
-            <a:lvl3pPr>
-              <a:buNone/>
-              <a:defRPr sz="830" baseline="0">
-                <a:solidFill>
-                  <a:srgbClr val="231F20"/>
-                </a:solidFill>
-                <a:latin typeface="Myriad Pro" panose="020B0503030403020204" pitchFamily="34" charset="0"/>
-              </a:defRPr>
-            </a:lvl3pPr>
-            <a:lvl4pPr>
-              <a:buNone/>
-              <a:defRPr sz="830" baseline="0">
-                <a:solidFill>
-                  <a:srgbClr val="231F20"/>
-                </a:solidFill>
-                <a:latin typeface="Myriad Pro" panose="020B0503030403020204" pitchFamily="34" charset="0"/>
-              </a:defRPr>
-            </a:lvl4pPr>
-            <a:lvl5pPr>
-              <a:buNone/>
-              <a:defRPr sz="830" baseline="0">
-                <a:solidFill>
-                  <a:srgbClr val="231F20"/>
-                </a:solidFill>
-                <a:latin typeface="Myriad Pro" panose="020B0503030403020204" pitchFamily="34" charset="0"/>
-              </a:defRPr>
-            </a:lvl5pPr>
-          </a:lstStyle>
-          <a:p>
-            <a:pPr lvl="0"/>
-            <a:r>
-              <a:rPr lang="uk-UA" dirty="0"/>
-              <a:t>Клацніть,</a:t>
-            </a:r>
-            <a:endParaRPr lang="en-US" dirty="0"/>
-          </a:p>
-          <a:p>
-            <a:pPr lvl="0"/>
-            <a:endParaRPr lang="uk-UA" dirty="0"/>
-          </a:p>
-        </p:txBody>
-      </p:sp>
-      <p:sp>
-        <p:nvSpPr>
-          <p:cNvPr id="29" name="TXT_MOTIF_STATS_CALLOUT">
-            <a:extLst>
-              <a:ext uri="{FF2B5EF4-FFF2-40B4-BE49-F238E27FC236}">
-                <a16:creationId xmlns:a16="http://schemas.microsoft.com/office/drawing/2014/main" id="{D343B36D-4567-682F-EB69-A9904C680CC9}"/>
-              </a:ext>
-            </a:extLst>
-          </p:cNvPr>
-          <p:cNvSpPr>
-            <a:spLocks noGrp="1"/>
-          </p:cNvSpPr>
-          <p:nvPr>
-            <p:ph type="body" sz="quarter" idx="18"/>
-          </p:nvPr>
-        </p:nvSpPr>
-        <p:spPr>
-          <a:xfrm>
-            <a:off x="2350799" y="6249599"/>
-            <a:ext cx="5036400" cy="370800"/>
-          </a:xfrm>
-        </p:spPr>
-        <p:txBody>
-          <a:bodyPr/>
-          <a:lstStyle>
-            <a:lvl1pPr>
-              <a:buNone/>
-              <a:defRPr sz="1180" baseline="0">
-                <a:solidFill>
-                  <a:srgbClr val="C5923B"/>
-                </a:solidFill>
-              </a:defRPr>
-            </a:lvl1pPr>
-            <a:lvl2pPr>
-              <a:buNone/>
-              <a:defRPr sz="1180" baseline="0">
-                <a:solidFill>
-                  <a:srgbClr val="C5923B"/>
-                </a:solidFill>
-              </a:defRPr>
-            </a:lvl2pPr>
-            <a:lvl3pPr>
-              <a:buNone/>
-              <a:defRPr sz="1180" baseline="0">
-                <a:solidFill>
-                  <a:srgbClr val="C5923B"/>
-                </a:solidFill>
-              </a:defRPr>
-            </a:lvl3pPr>
-            <a:lvl4pPr>
-              <a:buNone/>
-              <a:defRPr sz="1180" baseline="0">
-                <a:solidFill>
-                  <a:srgbClr val="C5923B"/>
-                </a:solidFill>
-              </a:defRPr>
-            </a:lvl4pPr>
-            <a:lvl5pPr>
-              <a:buNone/>
-              <a:defRPr sz="1180" baseline="0">
-                <a:solidFill>
-                  <a:srgbClr val="C5923B"/>
-                </a:solidFill>
-              </a:defRPr>
-            </a:lvl5pPr>
-          </a:lstStyle>
-          <a:p>
-            <a:pPr lvl="0"/>
-            <a:r>
-              <a:rPr lang="uk-UA" dirty="0"/>
-              <a:t>Клацніть, щоб відредагувати стилі зразків тексту</a:t>
-            </a:r>
-          </a:p>
-        </p:txBody>
-      </p:sp>
-      <p:sp>
-        <p:nvSpPr>
-          <p:cNvPr id="31" name="IMG_MOTIF_1_PHOTO">
-            <a:extLst>
-              <a:ext uri="{FF2B5EF4-FFF2-40B4-BE49-F238E27FC236}">
-                <a16:creationId xmlns:a16="http://schemas.microsoft.com/office/drawing/2014/main" id="{62B219E3-1E42-91D4-A426-7F00E974FDF9}"/>
-              </a:ext>
-            </a:extLst>
-          </p:cNvPr>
-          <p:cNvSpPr>
-            <a:spLocks noGrp="1"/>
-          </p:cNvSpPr>
-          <p:nvPr>
-            <p:ph type="pic" sz="quarter" idx="19"/>
-          </p:nvPr>
-        </p:nvSpPr>
-        <p:spPr>
-          <a:xfrm>
-            <a:off x="1457999" y="2152800"/>
-            <a:ext cx="2469600" cy="1389600"/>
-          </a:xfrm>
-        </p:spPr>
-        <p:txBody>
-          <a:bodyPr/>
-          <a:lstStyle/>
-          <a:p>
-            <a:endParaRPr lang="ru-UA"/>
-          </a:p>
-        </p:txBody>
-      </p:sp>
-      <p:sp>
-        <p:nvSpPr>
-          <p:cNvPr id="33" name="IMG_MOTIF_1_BACKGROUND">
-            <a:extLst>
-              <a:ext uri="{FF2B5EF4-FFF2-40B4-BE49-F238E27FC236}">
-                <a16:creationId xmlns:a16="http://schemas.microsoft.com/office/drawing/2014/main" id="{2D2D4949-E3F2-C23B-4310-445056A8B513}"/>
-              </a:ext>
-            </a:extLst>
-          </p:cNvPr>
-          <p:cNvSpPr>
-            <a:spLocks noGrp="1"/>
-          </p:cNvSpPr>
-          <p:nvPr>
-            <p:ph type="pic" sz="quarter" idx="20"/>
-          </p:nvPr>
-        </p:nvSpPr>
-        <p:spPr>
-          <a:xfrm>
-            <a:off x="4748400" y="2152800"/>
-            <a:ext cx="2469600" cy="1389600"/>
-          </a:xfrm>
-        </p:spPr>
-        <p:txBody>
-          <a:bodyPr/>
-          <a:lstStyle/>
-          <a:p>
-            <a:endParaRPr lang="ru-UA"/>
-          </a:p>
-        </p:txBody>
-      </p:sp>
-      <p:sp>
-        <p:nvSpPr>
-          <p:cNvPr id="35" name="IMG_MOTIF_1_MASK">
-            <a:extLst>
-              <a:ext uri="{FF2B5EF4-FFF2-40B4-BE49-F238E27FC236}">
-                <a16:creationId xmlns:a16="http://schemas.microsoft.com/office/drawing/2014/main" id="{8E098B13-ABE9-2F3F-C2D3-6B0A5A4B6274}"/>
-              </a:ext>
-            </a:extLst>
-          </p:cNvPr>
-          <p:cNvSpPr>
-            <a:spLocks noGrp="1"/>
-          </p:cNvSpPr>
-          <p:nvPr>
-            <p:ph type="pic" sz="quarter" idx="21"/>
-          </p:nvPr>
-        </p:nvSpPr>
-        <p:spPr>
-          <a:xfrm>
-            <a:off x="8038800" y="2152800"/>
-            <a:ext cx="2469600" cy="1389600"/>
-          </a:xfrm>
-        </p:spPr>
-        <p:txBody>
-          <a:bodyPr/>
-          <a:lstStyle/>
-          <a:p>
-            <a:endParaRPr lang="ru-UA"/>
-          </a:p>
-        </p:txBody>
-      </p:sp>
-      <p:sp>
-        <p:nvSpPr>
-          <p:cNvPr id="37" name="IMG_MOTIF_2_PHOTO">
-            <a:extLst>
-              <a:ext uri="{FF2B5EF4-FFF2-40B4-BE49-F238E27FC236}">
-                <a16:creationId xmlns:a16="http://schemas.microsoft.com/office/drawing/2014/main" id="{5DB5C86A-F711-1BC6-EFEB-670FEDE78127}"/>
-              </a:ext>
-            </a:extLst>
-          </p:cNvPr>
-          <p:cNvSpPr>
-            <a:spLocks noGrp="1"/>
-          </p:cNvSpPr>
-          <p:nvPr>
-            <p:ph type="pic" sz="quarter" idx="22"/>
-          </p:nvPr>
-        </p:nvSpPr>
-        <p:spPr>
-          <a:xfrm>
-            <a:off x="1457999" y="3542400"/>
-            <a:ext cx="2469600" cy="1389600"/>
-          </a:xfrm>
-        </p:spPr>
-        <p:txBody>
-          <a:bodyPr/>
-          <a:lstStyle/>
-          <a:p>
-            <a:endParaRPr lang="ru-UA"/>
-          </a:p>
-        </p:txBody>
-      </p:sp>
-      <p:sp>
-        <p:nvSpPr>
-          <p:cNvPr id="39" name="IMG_MOTIF_2_BACKGROUND">
-            <a:extLst>
-              <a:ext uri="{FF2B5EF4-FFF2-40B4-BE49-F238E27FC236}">
-                <a16:creationId xmlns:a16="http://schemas.microsoft.com/office/drawing/2014/main" id="{1AE5AD94-51B2-3FE1-F876-774397D828D8}"/>
-              </a:ext>
-            </a:extLst>
-          </p:cNvPr>
-          <p:cNvSpPr>
-            <a:spLocks noGrp="1"/>
-          </p:cNvSpPr>
-          <p:nvPr>
-            <p:ph type="pic" sz="quarter" idx="23"/>
-          </p:nvPr>
-        </p:nvSpPr>
-        <p:spPr>
-          <a:xfrm>
-            <a:off x="4748400" y="3542399"/>
-            <a:ext cx="2469600" cy="1389600"/>
-          </a:xfrm>
-        </p:spPr>
-        <p:txBody>
-          <a:bodyPr/>
-          <a:lstStyle/>
-          <a:p>
-            <a:endParaRPr lang="ru-UA"/>
-          </a:p>
-        </p:txBody>
-      </p:sp>
-      <p:sp>
-        <p:nvSpPr>
-          <p:cNvPr id="41" name="IMG_MOTIF_2_MASK">
-            <a:extLst>
-              <a:ext uri="{FF2B5EF4-FFF2-40B4-BE49-F238E27FC236}">
-                <a16:creationId xmlns:a16="http://schemas.microsoft.com/office/drawing/2014/main" id="{E06252D1-117D-D50C-F31A-306885677628}"/>
-              </a:ext>
-            </a:extLst>
-          </p:cNvPr>
-          <p:cNvSpPr>
-            <a:spLocks noGrp="1"/>
-          </p:cNvSpPr>
-          <p:nvPr>
-            <p:ph type="pic" sz="quarter" idx="24"/>
-          </p:nvPr>
-        </p:nvSpPr>
-        <p:spPr>
-          <a:xfrm>
-            <a:off x="8038799" y="3542399"/>
-            <a:ext cx="2469600" cy="1389600"/>
-          </a:xfrm>
-        </p:spPr>
-        <p:txBody>
-          <a:bodyPr/>
-          <a:lstStyle/>
-          <a:p>
-            <a:endParaRPr lang="ru-UA"/>
-          </a:p>
-        </p:txBody>
-      </p:sp>
-      <p:sp>
-        <p:nvSpPr>
-          <p:cNvPr id="43" name="IMG_MOTIF_3_PHOTO">
-            <a:extLst>
-              <a:ext uri="{FF2B5EF4-FFF2-40B4-BE49-F238E27FC236}">
-                <a16:creationId xmlns:a16="http://schemas.microsoft.com/office/drawing/2014/main" id="{1AF4C320-E0F4-8D35-AB7E-39ABA5520542}"/>
-              </a:ext>
-            </a:extLst>
-          </p:cNvPr>
-          <p:cNvSpPr>
-            <a:spLocks noGrp="1"/>
-          </p:cNvSpPr>
-          <p:nvPr>
-            <p:ph type="pic" sz="quarter" idx="25"/>
-          </p:nvPr>
-        </p:nvSpPr>
-        <p:spPr>
-          <a:xfrm>
-            <a:off x="1457999" y="4932000"/>
-            <a:ext cx="2469600" cy="1188000"/>
-          </a:xfrm>
-        </p:spPr>
-        <p:txBody>
-          <a:bodyPr/>
-          <a:lstStyle/>
-          <a:p>
-            <a:endParaRPr lang="ru-UA"/>
-          </a:p>
-        </p:txBody>
-      </p:sp>
-      <p:sp>
-        <p:nvSpPr>
-          <p:cNvPr id="45" name="IMG_MOTIF_3_BACKGROUND">
-            <a:extLst>
-              <a:ext uri="{FF2B5EF4-FFF2-40B4-BE49-F238E27FC236}">
-                <a16:creationId xmlns:a16="http://schemas.microsoft.com/office/drawing/2014/main" id="{E013E4AB-5C01-4C91-69BD-8D27BAEB6C5E}"/>
-              </a:ext>
-            </a:extLst>
-          </p:cNvPr>
-          <p:cNvSpPr>
-            <a:spLocks noGrp="1"/>
-          </p:cNvSpPr>
-          <p:nvPr>
-            <p:ph type="pic" sz="quarter" idx="26"/>
-          </p:nvPr>
-        </p:nvSpPr>
-        <p:spPr>
-          <a:xfrm>
-            <a:off x="4748400" y="4932000"/>
-            <a:ext cx="2469600" cy="1188000"/>
-          </a:xfrm>
-        </p:spPr>
-        <p:txBody>
-          <a:bodyPr/>
-          <a:lstStyle/>
-          <a:p>
-            <a:endParaRPr lang="ru-UA"/>
-          </a:p>
-        </p:txBody>
-      </p:sp>
-      <p:sp>
-        <p:nvSpPr>
-          <p:cNvPr id="47" name="IMG_MOTIF_3_MASK">
-            <a:extLst>
-              <a:ext uri="{FF2B5EF4-FFF2-40B4-BE49-F238E27FC236}">
-                <a16:creationId xmlns:a16="http://schemas.microsoft.com/office/drawing/2014/main" id="{CAE27978-B1B0-FE06-8660-9091E8475261}"/>
-              </a:ext>
-            </a:extLst>
-          </p:cNvPr>
-          <p:cNvSpPr>
-            <a:spLocks noGrp="1"/>
-          </p:cNvSpPr>
-          <p:nvPr>
-            <p:ph type="pic" sz="quarter" idx="27"/>
-          </p:nvPr>
-        </p:nvSpPr>
-        <p:spPr>
-          <a:xfrm>
-            <a:off x="8038799" y="4932000"/>
-            <a:ext cx="2469600" cy="1188000"/>
-          </a:xfrm>
-        </p:spPr>
-        <p:txBody>
-          <a:bodyPr/>
-          <a:lstStyle/>
-          <a:p>
-            <a:endParaRPr lang="ru-UA"/>
-          </a:p>
-        </p:txBody>
-      </p:sp>
     </p:spTree>
     <p:extLst>
       <p:ext uri="{BB962C8B-B14F-4D97-AF65-F5344CB8AC3E}">
-        <p14:creationId xmlns:p14="http://schemas.microsoft.com/office/powerpoint/2010/main" val="934827309"/>
+        <p14:creationId xmlns:p14="http://schemas.microsoft.com/office/powerpoint/2010/main" val="2591900734"/>
       </p:ext>
     </p:extLst>
   </p:cSld>
@@ -4674,7 +5402,7 @@
           <a:p>
             <a:fld id="{3326DFF1-F6F8-444D-B677-7690BD10E8E8}" type="datetimeFigureOut">
               <a:rPr lang="ru-UA" smtClean="0"/>
-              <a:t>21.08.2026</a:t>
+              <a:t>27.08.2026</a:t>
             </a:fld>
             <a:endParaRPr lang="ru-UA"/>
           </a:p>
@@ -4785,7 +5513,7 @@
           <p:nvPr userDrawn="1"/>
         </p:nvPicPr>
         <p:blipFill>
-          <a:blip r:embed="rId9">
+          <a:blip r:embed="rId10">
             <a:extLst>
               <a:ext uri="{28A0092B-C50C-407E-A947-70E740481C1C}">
                 <a14:useLocalDpi xmlns:a14="http://schemas.microsoft.com/office/drawing/2010/main" val="0"/>
@@ -4817,11 +5545,12 @@
   <p:sldLayoutIdLst>
     <p:sldLayoutId id="2147483660" r:id="rId1"/>
     <p:sldLayoutId id="2147483661" r:id="rId2"/>
-    <p:sldLayoutId id="2147483662" r:id="rId3"/>
-    <p:sldLayoutId id="2147483663" r:id="rId4"/>
-    <p:sldLayoutId id="2147483649" r:id="rId5"/>
-    <p:sldLayoutId id="2147483664" r:id="rId6"/>
+    <p:sldLayoutId id="2147483664" r:id="rId3"/>
+    <p:sldLayoutId id="2147483662" r:id="rId4"/>
+    <p:sldLayoutId id="2147483663" r:id="rId5"/>
+    <p:sldLayoutId id="2147483649" r:id="rId6"/>
     <p:sldLayoutId id="2147483665" r:id="rId7"/>
+    <p:sldLayoutId id="2147483666" r:id="rId8"/>
   </p:sldLayoutIdLst>
   <p:txStyles>
     <p:titleStyle>

</xml_diff>

<commit_message>
Fix PAGE_01 headline z-order behind full-bleed photo, mask orphaned PAGE_03 plate, fill PAGE_06 computed fields; template text fixes
</commit_message>
<xml_diff>
--- a/templates/master_v01.pptx
+++ b/templates/master_v01.pptx
@@ -5,11 +5,8 @@
     <p:sldMasterId id="2147483648" r:id="rId1"/>
   </p:sldMasterIdLst>
   <p:notesMasterIdLst>
-    <p:notesMasterId r:id="rId3"/>
+    <p:notesMasterId r:id="rId2"/>
   </p:notesMasterIdLst>
-  <p:sldIdLst>
-    <p:sldId id="256" r:id="rId2"/>
-  </p:sldIdLst>
   <p:sldSz cx="12192000" cy="6858000"/>
   <p:notesSz cx="6858000" cy="9144000"/>
   <p:defaultTextStyle>
@@ -723,12 +720,12 @@
         </p:spPr>
         <p:txBody>
           <a:bodyPr wrap="square" rtlCol="0">
-            <a:spAutoFit/>
+            <a:noAutofit/>
           </a:bodyPr>
           <a:lstStyle/>
           <a:p>
             <a:r>
-              <a:rPr lang="de-DE" sz="3292" baseline="0" dirty="0">
+              <a:rPr lang="de-DE" sz="3292" b="1" i="0" baseline="0" dirty="0">
                 <a:solidFill>
                   <a:srgbClr val="F2F0EE"/>
                 </a:solidFill>
@@ -736,15 +733,16 @@
               </a:rPr>
               <a:t>Wir machen Ihre Besucher</a:t>
             </a:r>
-            <a:endParaRPr lang="uk-UA" sz="3292" baseline="0" dirty="0">
+            <a:endParaRPr lang="uk-UA" sz="3292" b="1" i="0" baseline="0" dirty="0">
               <a:solidFill>
                 <a:srgbClr val="F2F0EE"/>
               </a:solidFill>
+              <a:latin typeface="Helvetica" panose="020B0604020202020204" pitchFamily="34" charset="0"/>
             </a:endParaRPr>
           </a:p>
           <a:p>
             <a:r>
-              <a:rPr lang="de-DE" sz="3292" baseline="0" dirty="0">
+              <a:rPr lang="de-DE" sz="3292" b="1" i="0" baseline="0" dirty="0">
                 <a:solidFill>
                   <a:srgbClr val="F2F0EE"/>
                 </a:solidFill>
@@ -752,10 +750,11 @@
               </a:rPr>
               <a:t>zu einem Teil Ihrer Geschichte.</a:t>
             </a:r>
-            <a:endParaRPr lang="ru-UA" sz="3292" baseline="0" dirty="0">
+            <a:endParaRPr lang="ru-UA" sz="3292" b="1" i="0" baseline="0" dirty="0">
               <a:solidFill>
                 <a:srgbClr val="F2F0EE"/>
               </a:solidFill>
+              <a:latin typeface="Helvetica" panose="020B0604020202020204" pitchFamily="34" charset="0"/>
             </a:endParaRPr>
           </a:p>
         </p:txBody>
@@ -7000,96 +6999,6 @@
     </p:otherStyle>
   </p:txStyles>
 </p:sldMaster>
-</file>
-
-<file path=ppt/slides/slide1.xml><?xml version="1.0" encoding="utf-8"?>
-<p:sld xmlns:a="http://schemas.openxmlformats.org/drawingml/2006/main" xmlns:r="http://schemas.openxmlformats.org/officeDocument/2006/relationships" xmlns:p="http://schemas.openxmlformats.org/presentationml/2006/main">
-  <p:cSld>
-    <p:spTree>
-      <p:nvGrpSpPr>
-        <p:cNvPr id="1" name=""/>
-        <p:cNvGrpSpPr/>
-        <p:nvPr/>
-      </p:nvGrpSpPr>
-      <p:grpSpPr>
-        <a:xfrm>
-          <a:off x="0" y="0"/>
-          <a:ext cx="0" cy="0"/>
-          <a:chOff x="0" y="0"/>
-          <a:chExt cx="0" cy="0"/>
-        </a:xfrm>
-      </p:grpSpPr>
-      <p:sp>
-        <p:nvSpPr>
-          <p:cNvPr id="2" name="Заголовок 1">
-            <a:extLst>
-              <a:ext uri="{FF2B5EF4-FFF2-40B4-BE49-F238E27FC236}">
-                <a16:creationId xmlns:a16="http://schemas.microsoft.com/office/drawing/2014/main" id="{129198F8-68E0-EF43-4C87-E91C41DCDCA6}"/>
-              </a:ext>
-            </a:extLst>
-          </p:cNvPr>
-          <p:cNvSpPr>
-            <a:spLocks noGrp="1"/>
-          </p:cNvSpPr>
-          <p:nvPr>
-            <p:ph type="ctrTitle" idx="4294967295"/>
-          </p:nvPr>
-        </p:nvSpPr>
-        <p:spPr>
-          <a:xfrm>
-            <a:off x="1524000" y="1122363"/>
-            <a:ext cx="9144000" cy="2387600"/>
-          </a:xfrm>
-        </p:spPr>
-        <p:txBody>
-          <a:bodyPr/>
-          <a:lstStyle/>
-          <a:p>
-            <a:endParaRPr lang="ru-UA"/>
-          </a:p>
-        </p:txBody>
-      </p:sp>
-      <p:sp>
-        <p:nvSpPr>
-          <p:cNvPr id="3" name="Підзаголовок 2">
-            <a:extLst>
-              <a:ext uri="{FF2B5EF4-FFF2-40B4-BE49-F238E27FC236}">
-                <a16:creationId xmlns:a16="http://schemas.microsoft.com/office/drawing/2014/main" id="{D71E68FD-3B1C-DB9E-0E41-F7A5EDE5227D}"/>
-              </a:ext>
-            </a:extLst>
-          </p:cNvPr>
-          <p:cNvSpPr>
-            <a:spLocks noGrp="1"/>
-          </p:cNvSpPr>
-          <p:nvPr>
-            <p:ph type="subTitle" idx="4294967295"/>
-          </p:nvPr>
-        </p:nvSpPr>
-        <p:spPr>
-          <a:xfrm>
-            <a:off x="1524000" y="3602038"/>
-            <a:ext cx="9144000" cy="1655762"/>
-          </a:xfrm>
-        </p:spPr>
-        <p:txBody>
-          <a:bodyPr/>
-          <a:lstStyle/>
-          <a:p>
-            <a:endParaRPr lang="ru-UA"/>
-          </a:p>
-        </p:txBody>
-      </p:sp>
-    </p:spTree>
-    <p:extLst>
-      <p:ext uri="{BB962C8B-B14F-4D97-AF65-F5344CB8AC3E}">
-        <p14:creationId xmlns:p14="http://schemas.microsoft.com/office/powerpoint/2010/main" val="3167417054"/>
-      </p:ext>
-    </p:extLst>
-  </p:cSld>
-  <p:clrMapOvr>
-    <a:masterClrMapping/>
-  </p:clrMapOvr>
-</p:sld>
 </file>
 
 <file path=ppt/theme/theme1.xml><?xml version="1.0" encoding="utf-8"?>

</xml_diff>

<commit_message>
Update WP9 test-data gitignore rule and redesigned templates
Ignore ad-hoc data/test_*.json files (same real-content rule as
example_01.json); sync template pptx binaries with latest PowerPoint edits.
</commit_message>
<xml_diff>
--- a/templates/master_v01.pptx
+++ b/templates/master_v01.pptx
@@ -197,7 +197,7 @@
           <a:p>
             <a:fld id="{EB8009A7-6B9F-4D93-88A2-45E8B8D87E2F}" type="datetimeFigureOut">
               <a:rPr lang="ru-UA" smtClean="0"/>
-              <a:t>27.08.2026</a:t>
+              <a:t>31.08.2026</a:t>
             </a:fld>
             <a:endParaRPr lang="ru-UA"/>
           </a:p>
@@ -6566,7 +6566,7 @@
           <a:p>
             <a:fld id="{3326DFF1-F6F8-444D-B677-7690BD10E8E8}" type="datetimeFigureOut">
               <a:rPr lang="ru-UA" smtClean="0"/>
-              <a:t>27.08.2026</a:t>
+              <a:t>31.08.2026</a:t>
             </a:fld>
             <a:endParaRPr lang="ru-UA"/>
           </a:p>

</xml_diff>